<commit_message>
add limestone barrens bioblitz
</commit_message>
<xml_diff>
--- a/figures/manual-edits/manual-rangecoverage.pptx
+++ b/figures/manual-edits/manual-rangecoverage.pptx
@@ -261,7 +261,7 @@
           <a:p>
             <a:fld id="{BE16F19D-6681-6141-A356-A6917F007572}" type="datetimeFigureOut">
               <a:rPr lang="en-CA" smtClean="0"/>
-              <a:t>2026-05-01</a:t>
+              <a:t>2026-05-13</a:t>
             </a:fld>
             <a:endParaRPr lang="en-CA"/>
           </a:p>
@@ -461,7 +461,7 @@
           <a:p>
             <a:fld id="{BE16F19D-6681-6141-A356-A6917F007572}" type="datetimeFigureOut">
               <a:rPr lang="en-CA" smtClean="0"/>
-              <a:t>2026-05-01</a:t>
+              <a:t>2026-05-13</a:t>
             </a:fld>
             <a:endParaRPr lang="en-CA"/>
           </a:p>
@@ -671,7 +671,7 @@
           <a:p>
             <a:fld id="{BE16F19D-6681-6141-A356-A6917F007572}" type="datetimeFigureOut">
               <a:rPr lang="en-CA" smtClean="0"/>
-              <a:t>2026-05-01</a:t>
+              <a:t>2026-05-13</a:t>
             </a:fld>
             <a:endParaRPr lang="en-CA"/>
           </a:p>
@@ -871,7 +871,7 @@
           <a:p>
             <a:fld id="{BE16F19D-6681-6141-A356-A6917F007572}" type="datetimeFigureOut">
               <a:rPr lang="en-CA" smtClean="0"/>
-              <a:t>2026-05-01</a:t>
+              <a:t>2026-05-13</a:t>
             </a:fld>
             <a:endParaRPr lang="en-CA"/>
           </a:p>
@@ -1147,7 +1147,7 @@
           <a:p>
             <a:fld id="{BE16F19D-6681-6141-A356-A6917F007572}" type="datetimeFigureOut">
               <a:rPr lang="en-CA" smtClean="0"/>
-              <a:t>2026-05-01</a:t>
+              <a:t>2026-05-13</a:t>
             </a:fld>
             <a:endParaRPr lang="en-CA"/>
           </a:p>
@@ -1415,7 +1415,7 @@
           <a:p>
             <a:fld id="{BE16F19D-6681-6141-A356-A6917F007572}" type="datetimeFigureOut">
               <a:rPr lang="en-CA" smtClean="0"/>
-              <a:t>2026-05-01</a:t>
+              <a:t>2026-05-13</a:t>
             </a:fld>
             <a:endParaRPr lang="en-CA"/>
           </a:p>
@@ -1830,7 +1830,7 @@
           <a:p>
             <a:fld id="{BE16F19D-6681-6141-A356-A6917F007572}" type="datetimeFigureOut">
               <a:rPr lang="en-CA" smtClean="0"/>
-              <a:t>2026-05-01</a:t>
+              <a:t>2026-05-13</a:t>
             </a:fld>
             <a:endParaRPr lang="en-CA"/>
           </a:p>
@@ -1972,7 +1972,7 @@
           <a:p>
             <a:fld id="{BE16F19D-6681-6141-A356-A6917F007572}" type="datetimeFigureOut">
               <a:rPr lang="en-CA" smtClean="0"/>
-              <a:t>2026-05-01</a:t>
+              <a:t>2026-05-13</a:t>
             </a:fld>
             <a:endParaRPr lang="en-CA"/>
           </a:p>
@@ -2085,7 +2085,7 @@
           <a:p>
             <a:fld id="{BE16F19D-6681-6141-A356-A6917F007572}" type="datetimeFigureOut">
               <a:rPr lang="en-CA" smtClean="0"/>
-              <a:t>2026-05-01</a:t>
+              <a:t>2026-05-13</a:t>
             </a:fld>
             <a:endParaRPr lang="en-CA"/>
           </a:p>
@@ -2398,7 +2398,7 @@
           <a:p>
             <a:fld id="{BE16F19D-6681-6141-A356-A6917F007572}" type="datetimeFigureOut">
               <a:rPr lang="en-CA" smtClean="0"/>
-              <a:t>2026-05-01</a:t>
+              <a:t>2026-05-13</a:t>
             </a:fld>
             <a:endParaRPr lang="en-CA"/>
           </a:p>
@@ -2687,7 +2687,7 @@
           <a:p>
             <a:fld id="{BE16F19D-6681-6141-A356-A6917F007572}" type="datetimeFigureOut">
               <a:rPr lang="en-CA" smtClean="0"/>
-              <a:t>2026-05-01</a:t>
+              <a:t>2026-05-13</a:t>
             </a:fld>
             <a:endParaRPr lang="en-CA"/>
           </a:p>
@@ -2930,7 +2930,7 @@
           <a:p>
             <a:fld id="{BE16F19D-6681-6141-A356-A6917F007572}" type="datetimeFigureOut">
               <a:rPr lang="en-CA" smtClean="0"/>
-              <a:t>2026-05-01</a:t>
+              <a:t>2026-05-13</a:t>
             </a:fld>
             <a:endParaRPr lang="en-CA"/>
           </a:p>
@@ -3355,10 +3355,10 @@
       </p:grpSpPr>
       <p:grpSp>
         <p:nvGrpSpPr>
-          <p:cNvPr id="40" name="Group 39">
-            <a:extLst>
-              <a:ext uri="{FF2B5EF4-FFF2-40B4-BE49-F238E27FC236}">
-                <a16:creationId xmlns:a16="http://schemas.microsoft.com/office/drawing/2014/main" id="{9C81884C-8FC1-BD2C-52E8-403694E538E7}"/>
+          <p:cNvPr id="9" name="Group 8">
+            <a:extLst>
+              <a:ext uri="{FF2B5EF4-FFF2-40B4-BE49-F238E27FC236}">
+                <a16:creationId xmlns:a16="http://schemas.microsoft.com/office/drawing/2014/main" id="{A289F822-E404-C5D1-AA2D-851E3B32D6D3}"/>
               </a:ext>
             </a:extLst>
           </p:cNvPr>
@@ -3367,70 +3367,18 @@
         </p:nvGrpSpPr>
         <p:grpSpPr>
           <a:xfrm>
-            <a:off x="1680202" y="-1343608"/>
+            <a:off x="1680202" y="-1332723"/>
             <a:ext cx="8446969" cy="11320728"/>
-            <a:chOff x="1680202" y="-1343608"/>
+            <a:chOff x="1680202" y="-1332723"/>
             <a:chExt cx="8446969" cy="11320728"/>
           </a:xfrm>
         </p:grpSpPr>
-        <p:sp>
-          <p:nvSpPr>
-            <p:cNvPr id="35" name="Rectangle 34">
+        <p:grpSp>
+          <p:nvGrpSpPr>
+            <p:cNvPr id="40" name="Group 39">
               <a:extLst>
                 <a:ext uri="{FF2B5EF4-FFF2-40B4-BE49-F238E27FC236}">
-                  <a16:creationId xmlns:a16="http://schemas.microsoft.com/office/drawing/2014/main" id="{BCDA4B85-5FB8-EA48-2193-74B52C81AF5B}"/>
-                </a:ext>
-              </a:extLst>
-            </p:cNvPr>
-            <p:cNvSpPr/>
-            <p:nvPr/>
-          </p:nvSpPr>
-          <p:spPr>
-            <a:xfrm>
-              <a:off x="1922106" y="-1343608"/>
-              <a:ext cx="8078819" cy="11320728"/>
-            </a:xfrm>
-            <a:prstGeom prst="rect">
-              <a:avLst/>
-            </a:prstGeom>
-            <a:solidFill>
-              <a:schemeClr val="bg1"/>
-            </a:solidFill>
-            <a:ln>
-              <a:noFill/>
-            </a:ln>
-          </p:spPr>
-          <p:style>
-            <a:lnRef idx="2">
-              <a:schemeClr val="accent1">
-                <a:shade val="15000"/>
-              </a:schemeClr>
-            </a:lnRef>
-            <a:fillRef idx="1">
-              <a:schemeClr val="accent1"/>
-            </a:fillRef>
-            <a:effectRef idx="0">
-              <a:schemeClr val="accent1"/>
-            </a:effectRef>
-            <a:fontRef idx="minor">
-              <a:schemeClr val="lt1"/>
-            </a:fontRef>
-          </p:style>
-          <p:txBody>
-            <a:bodyPr rtlCol="0" anchor="ctr"/>
-            <a:lstStyle/>
-            <a:p>
-              <a:pPr algn="ctr"/>
-              <a:endParaRPr lang="en-CA"/>
-            </a:p>
-          </p:txBody>
-        </p:sp>
-        <p:grpSp>
-          <p:nvGrpSpPr>
-            <p:cNvPr id="36" name="Group 35">
-              <a:extLst>
-                <a:ext uri="{FF2B5EF4-FFF2-40B4-BE49-F238E27FC236}">
-                  <a16:creationId xmlns:a16="http://schemas.microsoft.com/office/drawing/2014/main" id="{116EE50D-9DC8-D00B-A3DB-5A93C96558A7}"/>
+                  <a16:creationId xmlns:a16="http://schemas.microsoft.com/office/drawing/2014/main" id="{9C81884C-8FC1-BD2C-52E8-403694E538E7}"/>
                 </a:ext>
               </a:extLst>
             </p:cNvPr>
@@ -3439,18 +3387,879 @@
           </p:nvGrpSpPr>
           <p:grpSpPr>
             <a:xfrm>
-              <a:off x="1680202" y="-1246736"/>
-              <a:ext cx="8446969" cy="11223856"/>
-              <a:chOff x="1680202" y="-1246736"/>
-              <a:chExt cx="8446969" cy="11223856"/>
+              <a:off x="1680202" y="-1332723"/>
+              <a:ext cx="8446969" cy="11320728"/>
+              <a:chOff x="1680202" y="-1343608"/>
+              <a:chExt cx="8446969" cy="11320728"/>
             </a:xfrm>
           </p:grpSpPr>
+          <p:sp>
+            <p:nvSpPr>
+              <p:cNvPr id="35" name="Rectangle 34">
+                <a:extLst>
+                  <a:ext uri="{FF2B5EF4-FFF2-40B4-BE49-F238E27FC236}">
+                    <a16:creationId xmlns:a16="http://schemas.microsoft.com/office/drawing/2014/main" id="{BCDA4B85-5FB8-EA48-2193-74B52C81AF5B}"/>
+                  </a:ext>
+                </a:extLst>
+              </p:cNvPr>
+              <p:cNvSpPr/>
+              <p:nvPr/>
+            </p:nvSpPr>
+            <p:spPr>
+              <a:xfrm>
+                <a:off x="1922106" y="-1343608"/>
+                <a:ext cx="8078819" cy="11320728"/>
+              </a:xfrm>
+              <a:prstGeom prst="rect">
+                <a:avLst/>
+              </a:prstGeom>
+              <a:solidFill>
+                <a:schemeClr val="bg1"/>
+              </a:solidFill>
+              <a:ln>
+                <a:noFill/>
+              </a:ln>
+            </p:spPr>
+            <p:style>
+              <a:lnRef idx="2">
+                <a:schemeClr val="accent1">
+                  <a:shade val="15000"/>
+                </a:schemeClr>
+              </a:lnRef>
+              <a:fillRef idx="1">
+                <a:schemeClr val="accent1"/>
+              </a:fillRef>
+              <a:effectRef idx="0">
+                <a:schemeClr val="accent1"/>
+              </a:effectRef>
+              <a:fontRef idx="minor">
+                <a:schemeClr val="lt1"/>
+              </a:fontRef>
+            </p:style>
+            <p:txBody>
+              <a:bodyPr rtlCol="0" anchor="ctr"/>
+              <a:lstStyle/>
+              <a:p>
+                <a:pPr algn="ctr"/>
+                <a:endParaRPr lang="en-CA"/>
+              </a:p>
+            </p:txBody>
+          </p:sp>
+          <p:grpSp>
+            <p:nvGrpSpPr>
+              <p:cNvPr id="36" name="Group 35">
+                <a:extLst>
+                  <a:ext uri="{FF2B5EF4-FFF2-40B4-BE49-F238E27FC236}">
+                    <a16:creationId xmlns:a16="http://schemas.microsoft.com/office/drawing/2014/main" id="{116EE50D-9DC8-D00B-A3DB-5A93C96558A7}"/>
+                  </a:ext>
+                </a:extLst>
+              </p:cNvPr>
+              <p:cNvGrpSpPr/>
+              <p:nvPr/>
+            </p:nvGrpSpPr>
+            <p:grpSpPr>
+              <a:xfrm>
+                <a:off x="1680202" y="-1246736"/>
+                <a:ext cx="8446969" cy="11223856"/>
+                <a:chOff x="1680202" y="-1246736"/>
+                <a:chExt cx="8446969" cy="11223856"/>
+              </a:xfrm>
+            </p:grpSpPr>
+            <p:pic>
+              <p:nvPicPr>
+                <p:cNvPr id="3" name="Picture 2" descr="A graph of different colored dots&#10;&#10;Description automatically generated">
+                  <a:extLst>
+                    <a:ext uri="{FF2B5EF4-FFF2-40B4-BE49-F238E27FC236}">
+                      <a16:creationId xmlns:a16="http://schemas.microsoft.com/office/drawing/2014/main" id="{0CFAEE01-C1F4-C52A-DFE0-50A04D621F9C}"/>
+                    </a:ext>
+                  </a:extLst>
+                </p:cNvPr>
+                <p:cNvPicPr>
+                  <a:picLocks noChangeAspect="1"/>
+                </p:cNvPicPr>
+                <p:nvPr/>
+              </p:nvPicPr>
+              <p:blipFill>
+                <a:blip r:embed="rId2"/>
+                <a:srcRect l="27530" b="7853"/>
+                <a:stretch/>
+              </p:blipFill>
+              <p:spPr>
+                <a:xfrm>
+                  <a:off x="3414931" y="5535951"/>
+                  <a:ext cx="6585994" cy="4441169"/>
+                </a:xfrm>
+                <a:prstGeom prst="rect">
+                  <a:avLst/>
+                </a:prstGeom>
+              </p:spPr>
+            </p:pic>
+            <p:sp>
+              <p:nvSpPr>
+                <p:cNvPr id="12" name="TextBox 11">
+                  <a:extLst>
+                    <a:ext uri="{FF2B5EF4-FFF2-40B4-BE49-F238E27FC236}">
+                      <a16:creationId xmlns:a16="http://schemas.microsoft.com/office/drawing/2014/main" id="{CA3E905E-D432-47E8-341C-073FC5CBAF02}"/>
+                    </a:ext>
+                  </a:extLst>
+                </p:cNvPr>
+                <p:cNvSpPr txBox="1"/>
+                <p:nvPr/>
+              </p:nvSpPr>
+              <p:spPr>
+                <a:xfrm>
+                  <a:off x="1922105" y="-1246736"/>
+                  <a:ext cx="8078819" cy="369332"/>
+                </a:xfrm>
+                <a:prstGeom prst="rect">
+                  <a:avLst/>
+                </a:prstGeom>
+                <a:noFill/>
+              </p:spPr>
+              <p:txBody>
+                <a:bodyPr wrap="square" rtlCol="0">
+                  <a:spAutoFit/>
+                </a:bodyPr>
+                <a:lstStyle/>
+                <a:p>
+                  <a:pPr algn="ctr"/>
+                  <a:r>
+                    <a:rPr lang="en-CA" b="1" dirty="0">
+                      <a:latin typeface="Roboto Condensed" pitchFamily="2" charset="0"/>
+                      <a:ea typeface="Roboto Condensed" pitchFamily="2" charset="0"/>
+                    </a:rPr>
+                    <a:t>New species observed per site</a:t>
+                  </a:r>
+                </a:p>
+              </p:txBody>
+            </p:sp>
+            <p:sp>
+              <p:nvSpPr>
+                <p:cNvPr id="15" name="TextBox 14">
+                  <a:extLst>
+                    <a:ext uri="{FF2B5EF4-FFF2-40B4-BE49-F238E27FC236}">
+                      <a16:creationId xmlns:a16="http://schemas.microsoft.com/office/drawing/2014/main" id="{5C0FEB8F-FA76-1FC5-1311-25D30F0732E0}"/>
+                    </a:ext>
+                  </a:extLst>
+                </p:cNvPr>
+                <p:cNvSpPr txBox="1"/>
+                <p:nvPr/>
+              </p:nvSpPr>
+              <p:spPr>
+                <a:xfrm>
+                  <a:off x="8235589" y="6995868"/>
+                  <a:ext cx="1653150" cy="523220"/>
+                </a:xfrm>
+                <a:prstGeom prst="rect">
+                  <a:avLst/>
+                </a:prstGeom>
+                <a:noFill/>
+              </p:spPr>
+              <p:txBody>
+                <a:bodyPr wrap="square" rtlCol="0">
+                  <a:spAutoFit/>
+                </a:bodyPr>
+                <a:lstStyle/>
+                <a:p>
+                  <a:pPr algn="ctr"/>
+                  <a:r>
+                    <a:rPr lang="en-CA" sz="1400" b="0" i="0" dirty="0">
+                      <a:effectLst/>
+                      <a:latin typeface="Roboto Condensed" pitchFamily="2" charset="0"/>
+                      <a:ea typeface="Roboto Condensed" pitchFamily="2" charset="0"/>
+                    </a:rPr>
+                    <a:t>Fetid Marigold </a:t>
+                  </a:r>
+                  <a:br>
+                    <a:rPr lang="en-CA" sz="1400" b="0" i="0" dirty="0">
+                      <a:effectLst/>
+                      <a:latin typeface="Roboto Condensed" pitchFamily="2" charset="0"/>
+                      <a:ea typeface="Roboto Condensed" pitchFamily="2" charset="0"/>
+                    </a:rPr>
+                  </a:br>
+                  <a:r>
+                    <a:rPr lang="en-CA" sz="1400" b="0" i="1" dirty="0" err="1">
+                      <a:effectLst/>
+                      <a:latin typeface="Roboto Condensed" pitchFamily="2" charset="0"/>
+                      <a:ea typeface="Roboto Condensed" pitchFamily="2" charset="0"/>
+                    </a:rPr>
+                    <a:t>Dyssodia</a:t>
+                  </a:r>
+                  <a:r>
+                    <a:rPr lang="en-CA" sz="1400" b="0" i="1" dirty="0">
+                      <a:effectLst/>
+                      <a:latin typeface="Roboto Condensed" pitchFamily="2" charset="0"/>
+                      <a:ea typeface="Roboto Condensed" pitchFamily="2" charset="0"/>
+                    </a:rPr>
+                    <a:t> </a:t>
+                  </a:r>
+                  <a:r>
+                    <a:rPr lang="en-CA" sz="1400" b="0" i="1" dirty="0" err="1">
+                      <a:effectLst/>
+                      <a:latin typeface="Roboto Condensed" pitchFamily="2" charset="0"/>
+                      <a:ea typeface="Roboto Condensed" pitchFamily="2" charset="0"/>
+                    </a:rPr>
+                    <a:t>papposa</a:t>
+                  </a:r>
+                  <a:endParaRPr lang="en-CA" sz="1400" b="0" i="0" dirty="0">
+                    <a:effectLst/>
+                    <a:latin typeface="Roboto Condensed" pitchFamily="2" charset="0"/>
+                    <a:ea typeface="Roboto Condensed" pitchFamily="2" charset="0"/>
+                  </a:endParaRPr>
+                </a:p>
+              </p:txBody>
+            </p:sp>
+            <p:sp>
+              <p:nvSpPr>
+                <p:cNvPr id="16" name="TextBox 15">
+                  <a:extLst>
+                    <a:ext uri="{FF2B5EF4-FFF2-40B4-BE49-F238E27FC236}">
+                      <a16:creationId xmlns:a16="http://schemas.microsoft.com/office/drawing/2014/main" id="{71A6322D-7225-36AF-EFBB-5AD11E4C2403}"/>
+                    </a:ext>
+                  </a:extLst>
+                </p:cNvPr>
+                <p:cNvSpPr txBox="1"/>
+                <p:nvPr/>
+              </p:nvSpPr>
+              <p:spPr>
+                <a:xfrm>
+                  <a:off x="5646745" y="6204099"/>
+                  <a:ext cx="1718277" cy="523220"/>
+                </a:xfrm>
+                <a:prstGeom prst="rect">
+                  <a:avLst/>
+                </a:prstGeom>
+                <a:noFill/>
+              </p:spPr>
+              <p:txBody>
+                <a:bodyPr wrap="square" rtlCol="0">
+                  <a:spAutoFit/>
+                </a:bodyPr>
+                <a:lstStyle>
+                  <a:defPPr>
+                    <a:defRPr lang="en-US"/>
+                  </a:defPPr>
+                  <a:lvl1pPr>
+                    <a:defRPr sz="1600" b="0" i="0">
+                      <a:effectLst/>
+                      <a:latin typeface="Roboto Condensed" pitchFamily="2" charset="0"/>
+                      <a:ea typeface="Roboto Condensed" pitchFamily="2" charset="0"/>
+                    </a:defRPr>
+                  </a:lvl1pPr>
+                </a:lstStyle>
+                <a:p>
+                  <a:r>
+                    <a:rPr lang="en-CA" sz="1400" dirty="0"/>
+                    <a:t>Blanding’s Turtle </a:t>
+                  </a:r>
+                </a:p>
+                <a:p>
+                  <a:r>
+                    <a:rPr lang="en-CA" sz="1400" i="1" dirty="0" err="1"/>
+                    <a:t>Emydoidea</a:t>
+                  </a:r>
+                  <a:r>
+                    <a:rPr lang="en-CA" sz="1400" i="1" dirty="0"/>
+                    <a:t> </a:t>
+                  </a:r>
+                  <a:r>
+                    <a:rPr lang="en-CA" sz="1400" i="1" dirty="0" err="1"/>
+                    <a:t>blandingii</a:t>
+                  </a:r>
+                  <a:endParaRPr lang="en-CA" sz="1400" i="1" dirty="0"/>
+                </a:p>
+              </p:txBody>
+            </p:sp>
+            <p:sp>
+              <p:nvSpPr>
+                <p:cNvPr id="17" name="TextBox 16">
+                  <a:extLst>
+                    <a:ext uri="{FF2B5EF4-FFF2-40B4-BE49-F238E27FC236}">
+                      <a16:creationId xmlns:a16="http://schemas.microsoft.com/office/drawing/2014/main" id="{469232AA-ECC9-809C-5DE4-11F959F5D248}"/>
+                    </a:ext>
+                  </a:extLst>
+                </p:cNvPr>
+                <p:cNvSpPr txBox="1"/>
+                <p:nvPr/>
+              </p:nvSpPr>
+              <p:spPr>
+                <a:xfrm>
+                  <a:off x="7580212" y="7851052"/>
+                  <a:ext cx="2546959" cy="523220"/>
+                </a:xfrm>
+                <a:prstGeom prst="rect">
+                  <a:avLst/>
+                </a:prstGeom>
+                <a:noFill/>
+              </p:spPr>
+              <p:txBody>
+                <a:bodyPr wrap="square" rtlCol="0">
+                  <a:spAutoFit/>
+                </a:bodyPr>
+                <a:lstStyle/>
+                <a:p>
+                  <a:r>
+                    <a:rPr lang="en-CA" sz="1400" b="0" i="0" dirty="0">
+                      <a:effectLst/>
+                      <a:latin typeface="Roboto Condensed" pitchFamily="2" charset="0"/>
+                      <a:ea typeface="Roboto Condensed" pitchFamily="2" charset="0"/>
+                    </a:rPr>
+                    <a:t>Vancouver Island Marmot</a:t>
+                  </a:r>
+                </a:p>
+                <a:p>
+                  <a:r>
+                    <a:rPr lang="en-CA" sz="1400" b="0" i="1" dirty="0">
+                      <a:effectLst/>
+                      <a:latin typeface="Roboto Condensed" pitchFamily="2" charset="0"/>
+                      <a:ea typeface="Roboto Condensed" pitchFamily="2" charset="0"/>
+                    </a:rPr>
+                    <a:t>Marmota </a:t>
+                  </a:r>
+                  <a:r>
+                    <a:rPr lang="en-CA" sz="1400" b="0" i="1" dirty="0" err="1">
+                      <a:effectLst/>
+                      <a:latin typeface="Roboto Condensed" pitchFamily="2" charset="0"/>
+                      <a:ea typeface="Roboto Condensed" pitchFamily="2" charset="0"/>
+                    </a:rPr>
+                    <a:t>vancouverensis</a:t>
+                  </a:r>
+                  <a:endParaRPr lang="en-CA" sz="1400" b="0" i="1" dirty="0">
+                    <a:effectLst/>
+                    <a:latin typeface="Roboto Condensed" pitchFamily="2" charset="0"/>
+                    <a:ea typeface="Roboto Condensed" pitchFamily="2" charset="0"/>
+                  </a:endParaRPr>
+                </a:p>
+              </p:txBody>
+            </p:sp>
+            <p:sp>
+              <p:nvSpPr>
+                <p:cNvPr id="19" name="TextBox 18">
+                  <a:extLst>
+                    <a:ext uri="{FF2B5EF4-FFF2-40B4-BE49-F238E27FC236}">
+                      <a16:creationId xmlns:a16="http://schemas.microsoft.com/office/drawing/2014/main" id="{0AD1CB78-99F8-B3C5-4D9F-8123809D6ED5}"/>
+                    </a:ext>
+                  </a:extLst>
+                </p:cNvPr>
+                <p:cNvSpPr txBox="1"/>
+                <p:nvPr/>
+              </p:nvSpPr>
+              <p:spPr>
+                <a:xfrm>
+                  <a:off x="5625176" y="8362386"/>
+                  <a:ext cx="4375748" cy="523220"/>
+                </a:xfrm>
+                <a:prstGeom prst="rect">
+                  <a:avLst/>
+                </a:prstGeom>
+                <a:noFill/>
+              </p:spPr>
+              <p:txBody>
+                <a:bodyPr wrap="square" rtlCol="0">
+                  <a:spAutoFit/>
+                </a:bodyPr>
+                <a:lstStyle>
+                  <a:defPPr>
+                    <a:defRPr lang="en-US"/>
+                  </a:defPPr>
+                  <a:lvl1pPr>
+                    <a:defRPr sz="1600" b="0" i="0">
+                      <a:effectLst/>
+                      <a:latin typeface="Roboto Condensed" pitchFamily="2" charset="0"/>
+                      <a:ea typeface="Roboto Condensed" pitchFamily="2" charset="0"/>
+                    </a:defRPr>
+                  </a:lvl1pPr>
+                </a:lstStyle>
+                <a:p>
+                  <a:r>
+                    <a:rPr lang="en-CA" sz="1400" dirty="0"/>
+                    <a:t>California Tortoiseshell </a:t>
+                  </a:r>
+                </a:p>
+                <a:p>
+                  <a:r>
+                    <a:rPr lang="en-CA" sz="1400" i="1" dirty="0" err="1"/>
+                    <a:t>Nymphalis</a:t>
+                  </a:r>
+                  <a:r>
+                    <a:rPr lang="en-CA" sz="1400" i="1" dirty="0"/>
+                    <a:t> californica </a:t>
+                  </a:r>
+                </a:p>
+              </p:txBody>
+            </p:sp>
+            <p:sp>
+              <p:nvSpPr>
+                <p:cNvPr id="21" name="TextBox 20">
+                  <a:extLst>
+                    <a:ext uri="{FF2B5EF4-FFF2-40B4-BE49-F238E27FC236}">
+                      <a16:creationId xmlns:a16="http://schemas.microsoft.com/office/drawing/2014/main" id="{9C4BE664-A364-9531-31BD-DC727A1E40D4}"/>
+                    </a:ext>
+                  </a:extLst>
+                </p:cNvPr>
+                <p:cNvSpPr txBox="1"/>
+                <p:nvPr/>
+              </p:nvSpPr>
+              <p:spPr>
+                <a:xfrm>
+                  <a:off x="5619344" y="6816498"/>
+                  <a:ext cx="2047644" cy="523220"/>
+                </a:xfrm>
+                <a:prstGeom prst="rect">
+                  <a:avLst/>
+                </a:prstGeom>
+                <a:noFill/>
+              </p:spPr>
+              <p:txBody>
+                <a:bodyPr wrap="square" rtlCol="0">
+                  <a:spAutoFit/>
+                </a:bodyPr>
+                <a:lstStyle>
+                  <a:defPPr>
+                    <a:defRPr lang="en-US"/>
+                  </a:defPPr>
+                  <a:lvl1pPr>
+                    <a:defRPr sz="1600" b="0" i="0">
+                      <a:effectLst/>
+                      <a:latin typeface="Roboto Condensed" pitchFamily="2" charset="0"/>
+                      <a:ea typeface="Roboto Condensed" pitchFamily="2" charset="0"/>
+                    </a:defRPr>
+                  </a:lvl1pPr>
+                </a:lstStyle>
+                <a:p>
+                  <a:r>
+                    <a:rPr lang="en-CA" sz="1400" dirty="0"/>
+                    <a:t>Spring Salamander</a:t>
+                  </a:r>
+                </a:p>
+                <a:p>
+                  <a:r>
+                    <a:rPr lang="en-CA" sz="1400" i="1" dirty="0" err="1"/>
+                    <a:t>Gyrinophilus</a:t>
+                  </a:r>
+                  <a:r>
+                    <a:rPr lang="en-CA" sz="1400" i="1" dirty="0"/>
+                    <a:t> </a:t>
+                  </a:r>
+                  <a:r>
+                    <a:rPr lang="en-CA" sz="1400" i="1" dirty="0" err="1"/>
+                    <a:t>porphyriticus</a:t>
+                  </a:r>
+                  <a:endParaRPr lang="en-CA" sz="1400" i="1" dirty="0"/>
+                </a:p>
+              </p:txBody>
+            </p:sp>
+            <p:cxnSp>
+              <p:nvCxnSpPr>
+                <p:cNvPr id="23" name="Straight Arrow Connector 22">
+                  <a:extLst>
+                    <a:ext uri="{FF2B5EF4-FFF2-40B4-BE49-F238E27FC236}">
+                      <a16:creationId xmlns:a16="http://schemas.microsoft.com/office/drawing/2014/main" id="{45B9CE47-56CC-2C60-26AB-144E4280EDC5}"/>
+                    </a:ext>
+                  </a:extLst>
+                </p:cNvPr>
+                <p:cNvCxnSpPr>
+                  <a:cxnSpLocks/>
+                </p:cNvCxnSpPr>
+                <p:nvPr/>
+              </p:nvCxnSpPr>
+              <p:spPr>
+                <a:xfrm flipH="1">
+                  <a:off x="5245721" y="6465709"/>
+                  <a:ext cx="427528" cy="0"/>
+                </a:xfrm>
+                <a:prstGeom prst="straightConnector1">
+                  <a:avLst/>
+                </a:prstGeom>
+                <a:ln>
+                  <a:tailEnd type="triangle"/>
+                </a:ln>
+              </p:spPr>
+              <p:style>
+                <a:lnRef idx="2">
+                  <a:schemeClr val="dk1"/>
+                </a:lnRef>
+                <a:fillRef idx="0">
+                  <a:schemeClr val="dk1"/>
+                </a:fillRef>
+                <a:effectRef idx="1">
+                  <a:schemeClr val="dk1"/>
+                </a:effectRef>
+                <a:fontRef idx="minor">
+                  <a:schemeClr val="tx1"/>
+                </a:fontRef>
+              </p:style>
+            </p:cxnSp>
+            <p:cxnSp>
+              <p:nvCxnSpPr>
+                <p:cNvPr id="29" name="Straight Arrow Connector 28">
+                  <a:extLst>
+                    <a:ext uri="{FF2B5EF4-FFF2-40B4-BE49-F238E27FC236}">
+                      <a16:creationId xmlns:a16="http://schemas.microsoft.com/office/drawing/2014/main" id="{90A4AC86-EB25-6703-90AC-C37179117492}"/>
+                    </a:ext>
+                  </a:extLst>
+                </p:cNvPr>
+                <p:cNvCxnSpPr>
+                  <a:cxnSpLocks/>
+                </p:cNvCxnSpPr>
+                <p:nvPr/>
+              </p:nvCxnSpPr>
+              <p:spPr>
+                <a:xfrm flipH="1">
+                  <a:off x="7142922" y="8139166"/>
+                  <a:ext cx="450542" cy="0"/>
+                </a:xfrm>
+                <a:prstGeom prst="straightConnector1">
+                  <a:avLst/>
+                </a:prstGeom>
+                <a:ln>
+                  <a:tailEnd type="triangle"/>
+                </a:ln>
+              </p:spPr>
+              <p:style>
+                <a:lnRef idx="2">
+                  <a:schemeClr val="dk1"/>
+                </a:lnRef>
+                <a:fillRef idx="0">
+                  <a:schemeClr val="dk1"/>
+                </a:fillRef>
+                <a:effectRef idx="1">
+                  <a:schemeClr val="dk1"/>
+                </a:effectRef>
+                <a:fontRef idx="minor">
+                  <a:schemeClr val="tx1"/>
+                </a:fontRef>
+              </p:style>
+            </p:cxnSp>
+            <p:cxnSp>
+              <p:nvCxnSpPr>
+                <p:cNvPr id="31" name="Straight Arrow Connector 30">
+                  <a:extLst>
+                    <a:ext uri="{FF2B5EF4-FFF2-40B4-BE49-F238E27FC236}">
+                      <a16:creationId xmlns:a16="http://schemas.microsoft.com/office/drawing/2014/main" id="{073F7B2F-029D-5026-FB78-AB944170E82D}"/>
+                    </a:ext>
+                  </a:extLst>
+                </p:cNvPr>
+                <p:cNvCxnSpPr>
+                  <a:cxnSpLocks/>
+                </p:cNvCxnSpPr>
+                <p:nvPr/>
+              </p:nvCxnSpPr>
+              <p:spPr>
+                <a:xfrm flipH="1">
+                  <a:off x="5192049" y="8584352"/>
+                  <a:ext cx="454696" cy="0"/>
+                </a:xfrm>
+                <a:prstGeom prst="straightConnector1">
+                  <a:avLst/>
+                </a:prstGeom>
+                <a:ln>
+                  <a:tailEnd type="triangle"/>
+                </a:ln>
+              </p:spPr>
+              <p:style>
+                <a:lnRef idx="2">
+                  <a:schemeClr val="dk1"/>
+                </a:lnRef>
+                <a:fillRef idx="0">
+                  <a:schemeClr val="dk1"/>
+                </a:fillRef>
+                <a:effectRef idx="1">
+                  <a:schemeClr val="dk1"/>
+                </a:effectRef>
+                <a:fontRef idx="minor">
+                  <a:schemeClr val="tx1"/>
+                </a:fontRef>
+              </p:style>
+            </p:cxnSp>
+            <p:cxnSp>
+              <p:nvCxnSpPr>
+                <p:cNvPr id="32" name="Straight Arrow Connector 31">
+                  <a:extLst>
+                    <a:ext uri="{FF2B5EF4-FFF2-40B4-BE49-F238E27FC236}">
+                      <a16:creationId xmlns:a16="http://schemas.microsoft.com/office/drawing/2014/main" id="{02B60A8A-2C31-8DA4-5D93-A408B0C9DE3F}"/>
+                    </a:ext>
+                  </a:extLst>
+                </p:cNvPr>
+                <p:cNvCxnSpPr>
+                  <a:cxnSpLocks/>
+                </p:cNvCxnSpPr>
+                <p:nvPr/>
+              </p:nvCxnSpPr>
+              <p:spPr>
+                <a:xfrm flipH="1">
+                  <a:off x="5124382" y="7086059"/>
+                  <a:ext cx="494962" cy="0"/>
+                </a:xfrm>
+                <a:prstGeom prst="straightConnector1">
+                  <a:avLst/>
+                </a:prstGeom>
+                <a:ln>
+                  <a:tailEnd type="triangle"/>
+                </a:ln>
+              </p:spPr>
+              <p:style>
+                <a:lnRef idx="2">
+                  <a:schemeClr val="dk1"/>
+                </a:lnRef>
+                <a:fillRef idx="0">
+                  <a:schemeClr val="dk1"/>
+                </a:fillRef>
+                <a:effectRef idx="1">
+                  <a:schemeClr val="dk1"/>
+                </a:effectRef>
+                <a:fontRef idx="minor">
+                  <a:schemeClr val="tx1"/>
+                </a:fontRef>
+              </p:style>
+            </p:cxnSp>
+            <p:sp>
+              <p:nvSpPr>
+                <p:cNvPr id="26" name="TextBox 25">
+                  <a:extLst>
+                    <a:ext uri="{FF2B5EF4-FFF2-40B4-BE49-F238E27FC236}">
+                      <a16:creationId xmlns:a16="http://schemas.microsoft.com/office/drawing/2014/main" id="{A87C2C98-34F5-3874-2356-D786060F0E3B}"/>
+                    </a:ext>
+                  </a:extLst>
+                </p:cNvPr>
+                <p:cNvSpPr txBox="1"/>
+                <p:nvPr/>
+              </p:nvSpPr>
+              <p:spPr>
+                <a:xfrm>
+                  <a:off x="1690822" y="6265654"/>
+                  <a:ext cx="1718277" cy="369332"/>
+                </a:xfrm>
+                <a:prstGeom prst="rect">
+                  <a:avLst/>
+                </a:prstGeom>
+                <a:noFill/>
+              </p:spPr>
+              <p:txBody>
+                <a:bodyPr wrap="square" rtlCol="0">
+                  <a:spAutoFit/>
+                </a:bodyPr>
+                <a:lstStyle>
+                  <a:defPPr>
+                    <a:defRPr lang="en-US"/>
+                  </a:defPPr>
+                  <a:lvl1pPr>
+                    <a:defRPr sz="1600" b="0" i="0">
+                      <a:effectLst/>
+                      <a:latin typeface="Roboto Condensed" pitchFamily="2" charset="0"/>
+                      <a:ea typeface="Roboto Condensed" pitchFamily="2" charset="0"/>
+                    </a:defRPr>
+                  </a:lvl1pPr>
+                </a:lstStyle>
+                <a:p>
+                  <a:pPr algn="r"/>
+                  <a:r>
+                    <a:rPr lang="en-CA" sz="1800" b="1" dirty="0"/>
+                    <a:t>Reptiles</a:t>
+                  </a:r>
+                  <a:endParaRPr lang="en-CA" sz="1800" b="1" i="1" dirty="0"/>
+                </a:p>
+              </p:txBody>
+            </p:sp>
+            <p:sp>
+              <p:nvSpPr>
+                <p:cNvPr id="28" name="TextBox 27">
+                  <a:extLst>
+                    <a:ext uri="{FF2B5EF4-FFF2-40B4-BE49-F238E27FC236}">
+                      <a16:creationId xmlns:a16="http://schemas.microsoft.com/office/drawing/2014/main" id="{D54E7786-C9ED-F8AD-D29D-78F85E1F041F}"/>
+                    </a:ext>
+                  </a:extLst>
+                </p:cNvPr>
+                <p:cNvSpPr txBox="1"/>
+                <p:nvPr/>
+              </p:nvSpPr>
+              <p:spPr>
+                <a:xfrm>
+                  <a:off x="1690822" y="6857368"/>
+                  <a:ext cx="1718277" cy="369332"/>
+                </a:xfrm>
+                <a:prstGeom prst="rect">
+                  <a:avLst/>
+                </a:prstGeom>
+                <a:noFill/>
+              </p:spPr>
+              <p:txBody>
+                <a:bodyPr wrap="square" rtlCol="0">
+                  <a:spAutoFit/>
+                </a:bodyPr>
+                <a:lstStyle>
+                  <a:defPPr>
+                    <a:defRPr lang="en-US"/>
+                  </a:defPPr>
+                  <a:lvl1pPr>
+                    <a:defRPr sz="1600" b="0" i="0">
+                      <a:effectLst/>
+                      <a:latin typeface="Roboto Condensed" pitchFamily="2" charset="0"/>
+                      <a:ea typeface="Roboto Condensed" pitchFamily="2" charset="0"/>
+                    </a:defRPr>
+                  </a:lvl1pPr>
+                </a:lstStyle>
+                <a:p>
+                  <a:pPr algn="r"/>
+                  <a:r>
+                    <a:rPr lang="en-CA" sz="1800" b="1" dirty="0"/>
+                    <a:t>Amphibians</a:t>
+                  </a:r>
+                  <a:endParaRPr lang="en-CA" sz="1800" b="1" i="1" dirty="0"/>
+                </a:p>
+              </p:txBody>
+            </p:sp>
+            <p:sp>
+              <p:nvSpPr>
+                <p:cNvPr id="30" name="TextBox 29">
+                  <a:extLst>
+                    <a:ext uri="{FF2B5EF4-FFF2-40B4-BE49-F238E27FC236}">
+                      <a16:creationId xmlns:a16="http://schemas.microsoft.com/office/drawing/2014/main" id="{A2A1A0C0-D5E6-1A77-4A3F-D0227C66F32D}"/>
+                    </a:ext>
+                  </a:extLst>
+                </p:cNvPr>
+                <p:cNvSpPr txBox="1"/>
+                <p:nvPr/>
+              </p:nvSpPr>
+              <p:spPr>
+                <a:xfrm>
+                  <a:off x="1690822" y="7398239"/>
+                  <a:ext cx="1718277" cy="369332"/>
+                </a:xfrm>
+                <a:prstGeom prst="rect">
+                  <a:avLst/>
+                </a:prstGeom>
+                <a:noFill/>
+              </p:spPr>
+              <p:txBody>
+                <a:bodyPr wrap="square" rtlCol="0">
+                  <a:spAutoFit/>
+                </a:bodyPr>
+                <a:lstStyle>
+                  <a:defPPr>
+                    <a:defRPr lang="en-US"/>
+                  </a:defPPr>
+                  <a:lvl1pPr>
+                    <a:defRPr sz="1600" b="0" i="0">
+                      <a:effectLst/>
+                      <a:latin typeface="Roboto Condensed" pitchFamily="2" charset="0"/>
+                      <a:ea typeface="Roboto Condensed" pitchFamily="2" charset="0"/>
+                    </a:defRPr>
+                  </a:lvl1pPr>
+                </a:lstStyle>
+                <a:p>
+                  <a:pPr algn="r"/>
+                  <a:r>
+                    <a:rPr lang="en-CA" sz="1800" b="1" dirty="0"/>
+                    <a:t>Plants</a:t>
+                  </a:r>
+                  <a:endParaRPr lang="en-CA" sz="1800" b="1" i="1" dirty="0"/>
+                </a:p>
+              </p:txBody>
+            </p:sp>
+            <p:sp>
+              <p:nvSpPr>
+                <p:cNvPr id="33" name="TextBox 32">
+                  <a:extLst>
+                    <a:ext uri="{FF2B5EF4-FFF2-40B4-BE49-F238E27FC236}">
+                      <a16:creationId xmlns:a16="http://schemas.microsoft.com/office/drawing/2014/main" id="{1C644551-AEA9-6C0A-0B54-81061AA14647}"/>
+                    </a:ext>
+                  </a:extLst>
+                </p:cNvPr>
+                <p:cNvSpPr txBox="1"/>
+                <p:nvPr/>
+              </p:nvSpPr>
+              <p:spPr>
+                <a:xfrm>
+                  <a:off x="1690822" y="7939111"/>
+                  <a:ext cx="1718277" cy="369332"/>
+                </a:xfrm>
+                <a:prstGeom prst="rect">
+                  <a:avLst/>
+                </a:prstGeom>
+                <a:noFill/>
+              </p:spPr>
+              <p:txBody>
+                <a:bodyPr wrap="square" rtlCol="0">
+                  <a:spAutoFit/>
+                </a:bodyPr>
+                <a:lstStyle>
+                  <a:defPPr>
+                    <a:defRPr lang="en-US"/>
+                  </a:defPPr>
+                  <a:lvl1pPr>
+                    <a:defRPr sz="1600" b="0" i="0">
+                      <a:effectLst/>
+                      <a:latin typeface="Roboto Condensed" pitchFamily="2" charset="0"/>
+                      <a:ea typeface="Roboto Condensed" pitchFamily="2" charset="0"/>
+                    </a:defRPr>
+                  </a:lvl1pPr>
+                </a:lstStyle>
+                <a:p>
+                  <a:pPr algn="r"/>
+                  <a:r>
+                    <a:rPr lang="en-CA" sz="1800" b="1" dirty="0"/>
+                    <a:t>Mammals</a:t>
+                  </a:r>
+                  <a:endParaRPr lang="en-CA" sz="1800" b="1" i="1" dirty="0"/>
+                </a:p>
+              </p:txBody>
+            </p:sp>
+            <p:sp>
+              <p:nvSpPr>
+                <p:cNvPr id="34" name="TextBox 33">
+                  <a:extLst>
+                    <a:ext uri="{FF2B5EF4-FFF2-40B4-BE49-F238E27FC236}">
+                      <a16:creationId xmlns:a16="http://schemas.microsoft.com/office/drawing/2014/main" id="{500919C0-92BA-00CD-29D8-653824E77EDB}"/>
+                    </a:ext>
+                  </a:extLst>
+                </p:cNvPr>
+                <p:cNvSpPr txBox="1"/>
+                <p:nvPr/>
+              </p:nvSpPr>
+              <p:spPr>
+                <a:xfrm>
+                  <a:off x="1680202" y="8479983"/>
+                  <a:ext cx="1718277" cy="369332"/>
+                </a:xfrm>
+                <a:prstGeom prst="rect">
+                  <a:avLst/>
+                </a:prstGeom>
+                <a:noFill/>
+              </p:spPr>
+              <p:txBody>
+                <a:bodyPr wrap="square" rtlCol="0">
+                  <a:spAutoFit/>
+                </a:bodyPr>
+                <a:lstStyle>
+                  <a:defPPr>
+                    <a:defRPr lang="en-US"/>
+                  </a:defPPr>
+                  <a:lvl1pPr>
+                    <a:defRPr sz="1600" b="0" i="0">
+                      <a:effectLst/>
+                      <a:latin typeface="Roboto Condensed" pitchFamily="2" charset="0"/>
+                      <a:ea typeface="Roboto Condensed" pitchFamily="2" charset="0"/>
+                    </a:defRPr>
+                  </a:lvl1pPr>
+                </a:lstStyle>
+                <a:p>
+                  <a:pPr algn="r"/>
+                  <a:r>
+                    <a:rPr lang="en-CA" sz="1800" b="1" dirty="0"/>
+                    <a:t>Butterflies</a:t>
+                  </a:r>
+                  <a:endParaRPr lang="en-CA" sz="1800" b="1" i="1" dirty="0"/>
+                </a:p>
+              </p:txBody>
+            </p:sp>
+          </p:grpSp>
           <p:pic>
             <p:nvPicPr>
-              <p:cNvPr id="3" name="Picture 2" descr="A graph of different colored dots&#10;&#10;Description automatically generated">
+              <p:cNvPr id="6" name="Picture 5" descr="A map of canada with different colored areas&#10;&#10;Description automatically generated">
                 <a:extLst>
                   <a:ext uri="{FF2B5EF4-FFF2-40B4-BE49-F238E27FC236}">
-                    <a16:creationId xmlns:a16="http://schemas.microsoft.com/office/drawing/2014/main" id="{0CFAEE01-C1F4-C52A-DFE0-50A04D621F9C}"/>
+                    <a16:creationId xmlns:a16="http://schemas.microsoft.com/office/drawing/2014/main" id="{1097B08F-4974-89E2-BEB0-C2B3B9DF2F5A}"/>
                   </a:ext>
                 </a:extLst>
               </p:cNvPr>
@@ -3460,14 +4269,14 @@
               <p:nvPr/>
             </p:nvPicPr>
             <p:blipFill>
-              <a:blip r:embed="rId2"/>
-              <a:srcRect l="27530" b="7853"/>
+              <a:blip r:embed="rId3"/>
+              <a:srcRect l="9343" t="4885" r="7997" b="8770"/>
               <a:stretch/>
             </p:blipFill>
             <p:spPr>
               <a:xfrm>
-                <a:off x="3414931" y="5535951"/>
-                <a:ext cx="6585994" cy="4441169"/>
+                <a:off x="2621748" y="-942072"/>
+                <a:ext cx="6948503" cy="6844918"/>
               </a:xfrm>
               <a:prstGeom prst="rect">
                 <a:avLst/>
@@ -3476,10 +4285,10 @@
           </p:pic>
           <p:sp>
             <p:nvSpPr>
-              <p:cNvPr id="12" name="TextBox 11">
+              <p:cNvPr id="7" name="TextBox 6">
                 <a:extLst>
                   <a:ext uri="{FF2B5EF4-FFF2-40B4-BE49-F238E27FC236}">
-                    <a16:creationId xmlns:a16="http://schemas.microsoft.com/office/drawing/2014/main" id="{CA3E905E-D432-47E8-341C-073FC5CBAF02}"/>
+                    <a16:creationId xmlns:a16="http://schemas.microsoft.com/office/drawing/2014/main" id="{2DDA9446-9E8A-A269-CB06-E4768CF2D279}"/>
                   </a:ext>
                 </a:extLst>
               </p:cNvPr>
@@ -3488,8 +4297,8 @@
             </p:nvSpPr>
             <p:spPr>
               <a:xfrm>
-                <a:off x="1922105" y="-1246736"/>
-                <a:ext cx="8078819" cy="369332"/>
+                <a:off x="3392681" y="359278"/>
+                <a:ext cx="1731701" cy="523220"/>
               </a:xfrm>
               <a:prstGeom prst="rect">
                 <a:avLst/>
@@ -3502,474 +4311,43 @@
               </a:bodyPr>
               <a:lstStyle/>
               <a:p>
-                <a:pPr algn="ctr"/>
+                <a:pPr algn="r"/>
                 <a:r>
-                  <a:rPr lang="en-CA" b="1" dirty="0">
-                    <a:latin typeface="Roboto Condensed" pitchFamily="2" charset="0"/>
-                    <a:ea typeface="Roboto Condensed" pitchFamily="2" charset="0"/>
-                  </a:rPr>
-                  <a:t>New species observed per site</a:t>
-                </a:r>
-              </a:p>
-            </p:txBody>
-          </p:sp>
-          <p:sp>
-            <p:nvSpPr>
-              <p:cNvPr id="15" name="TextBox 14">
-                <a:extLst>
-                  <a:ext uri="{FF2B5EF4-FFF2-40B4-BE49-F238E27FC236}">
-                    <a16:creationId xmlns:a16="http://schemas.microsoft.com/office/drawing/2014/main" id="{5C0FEB8F-FA76-1FC5-1311-25D30F0732E0}"/>
-                  </a:ext>
-                </a:extLst>
-              </p:cNvPr>
-              <p:cNvSpPr txBox="1"/>
-              <p:nvPr/>
-            </p:nvSpPr>
-            <p:spPr>
-              <a:xfrm>
-                <a:off x="8235589" y="6995868"/>
-                <a:ext cx="1653150" cy="523220"/>
-              </a:xfrm>
-              <a:prstGeom prst="rect">
-                <a:avLst/>
-              </a:prstGeom>
-              <a:noFill/>
-            </p:spPr>
-            <p:txBody>
-              <a:bodyPr wrap="square" rtlCol="0">
-                <a:spAutoFit/>
-              </a:bodyPr>
-              <a:lstStyle/>
-              <a:p>
-                <a:pPr algn="ctr"/>
-                <a:r>
-                  <a:rPr lang="en-CA" sz="1400" b="0" i="0" dirty="0">
+                  <a:rPr lang="en-CA" sz="1400" b="0" i="0" u="none" strike="noStrike" dirty="0">
+                    <a:solidFill>
+                      <a:srgbClr val="000000"/>
+                    </a:solidFill>
                     <a:effectLst/>
                     <a:latin typeface="Roboto Condensed" pitchFamily="2" charset="0"/>
                     <a:ea typeface="Roboto Condensed" pitchFamily="2" charset="0"/>
                   </a:rPr>
-                  <a:t>Fetid Marigold </a:t>
+                  <a:t>Expedition Fiord Arctic Bioblitz</a:t>
                 </a:r>
-                <a:br>
-                  <a:rPr lang="en-CA" sz="1400" b="0" i="0" dirty="0">
-                    <a:effectLst/>
-                    <a:latin typeface="Roboto Condensed" pitchFamily="2" charset="0"/>
-                    <a:ea typeface="Roboto Condensed" pitchFamily="2" charset="0"/>
-                  </a:rPr>
-                </a:br>
-                <a:r>
-                  <a:rPr lang="en-CA" sz="1400" b="0" i="1" dirty="0" err="1">
-                    <a:effectLst/>
-                    <a:latin typeface="Roboto Condensed" pitchFamily="2" charset="0"/>
-                    <a:ea typeface="Roboto Condensed" pitchFamily="2" charset="0"/>
-                  </a:rPr>
-                  <a:t>Dyssodia</a:t>
-                </a:r>
-                <a:r>
-                  <a:rPr lang="en-CA" sz="1400" b="0" i="1" dirty="0">
-                    <a:effectLst/>
-                    <a:latin typeface="Roboto Condensed" pitchFamily="2" charset="0"/>
-                    <a:ea typeface="Roboto Condensed" pitchFamily="2" charset="0"/>
-                  </a:rPr>
-                  <a:t> </a:t>
-                </a:r>
-                <a:r>
-                  <a:rPr lang="en-CA" sz="1400" b="0" i="1" dirty="0" err="1">
-                    <a:effectLst/>
-                    <a:latin typeface="Roboto Condensed" pitchFamily="2" charset="0"/>
-                    <a:ea typeface="Roboto Condensed" pitchFamily="2" charset="0"/>
-                  </a:rPr>
-                  <a:t>papposa</a:t>
-                </a:r>
-                <a:endParaRPr lang="en-CA" sz="1400" b="0" i="0" dirty="0">
-                  <a:effectLst/>
+                <a:endParaRPr lang="en-CA" sz="1400" dirty="0">
                   <a:latin typeface="Roboto Condensed" pitchFamily="2" charset="0"/>
                   <a:ea typeface="Roboto Condensed" pitchFamily="2" charset="0"/>
                 </a:endParaRPr>
               </a:p>
             </p:txBody>
           </p:sp>
-          <p:sp>
-            <p:nvSpPr>
-              <p:cNvPr id="16" name="TextBox 15">
+          <p:cxnSp>
+            <p:nvCxnSpPr>
+              <p:cNvPr id="24" name="Straight Arrow Connector 23">
                 <a:extLst>
                   <a:ext uri="{FF2B5EF4-FFF2-40B4-BE49-F238E27FC236}">
-                    <a16:creationId xmlns:a16="http://schemas.microsoft.com/office/drawing/2014/main" id="{71A6322D-7225-36AF-EFBB-5AD11E4C2403}"/>
-                  </a:ext>
-                </a:extLst>
-              </p:cNvPr>
-              <p:cNvSpPr txBox="1"/>
-              <p:nvPr/>
-            </p:nvSpPr>
-            <p:spPr>
-              <a:xfrm>
-                <a:off x="5646745" y="6204099"/>
-                <a:ext cx="1718277" cy="523220"/>
-              </a:xfrm>
-              <a:prstGeom prst="rect">
-                <a:avLst/>
-              </a:prstGeom>
-              <a:noFill/>
-            </p:spPr>
-            <p:txBody>
-              <a:bodyPr wrap="square" rtlCol="0">
-                <a:spAutoFit/>
-              </a:bodyPr>
-              <a:lstStyle>
-                <a:defPPr>
-                  <a:defRPr lang="en-US"/>
-                </a:defPPr>
-                <a:lvl1pPr>
-                  <a:defRPr sz="1600" b="0" i="0">
-                    <a:effectLst/>
-                    <a:latin typeface="Roboto Condensed" pitchFamily="2" charset="0"/>
-                    <a:ea typeface="Roboto Condensed" pitchFamily="2" charset="0"/>
-                  </a:defRPr>
-                </a:lvl1pPr>
-              </a:lstStyle>
-              <a:p>
-                <a:r>
-                  <a:rPr lang="en-CA" sz="1400" dirty="0"/>
-                  <a:t>Blanding’s Turtle </a:t>
-                </a:r>
-              </a:p>
-              <a:p>
-                <a:r>
-                  <a:rPr lang="en-CA" sz="1400" i="1" dirty="0" err="1"/>
-                  <a:t>Emydoidea</a:t>
-                </a:r>
-                <a:r>
-                  <a:rPr lang="en-CA" sz="1400" i="1" dirty="0"/>
-                  <a:t> </a:t>
-                </a:r>
-                <a:r>
-                  <a:rPr lang="en-CA" sz="1400" i="1" dirty="0" err="1"/>
-                  <a:t>blandingii</a:t>
-                </a:r>
-                <a:endParaRPr lang="en-CA" sz="1400" i="1" dirty="0"/>
-              </a:p>
-            </p:txBody>
-          </p:sp>
-          <p:sp>
-            <p:nvSpPr>
-              <p:cNvPr id="17" name="TextBox 16">
-                <a:extLst>
-                  <a:ext uri="{FF2B5EF4-FFF2-40B4-BE49-F238E27FC236}">
-                    <a16:creationId xmlns:a16="http://schemas.microsoft.com/office/drawing/2014/main" id="{469232AA-ECC9-809C-5DE4-11F959F5D248}"/>
-                  </a:ext>
-                </a:extLst>
-              </p:cNvPr>
-              <p:cNvSpPr txBox="1"/>
-              <p:nvPr/>
-            </p:nvSpPr>
-            <p:spPr>
-              <a:xfrm>
-                <a:off x="7580212" y="7851052"/>
-                <a:ext cx="2546959" cy="523220"/>
-              </a:xfrm>
-              <a:prstGeom prst="rect">
-                <a:avLst/>
-              </a:prstGeom>
-              <a:noFill/>
-            </p:spPr>
-            <p:txBody>
-              <a:bodyPr wrap="square" rtlCol="0">
-                <a:spAutoFit/>
-              </a:bodyPr>
-              <a:lstStyle/>
-              <a:p>
-                <a:r>
-                  <a:rPr lang="en-CA" sz="1400" b="0" i="0" dirty="0">
-                    <a:effectLst/>
-                    <a:latin typeface="Roboto Condensed" pitchFamily="2" charset="0"/>
-                    <a:ea typeface="Roboto Condensed" pitchFamily="2" charset="0"/>
-                  </a:rPr>
-                  <a:t>Vancouver Island Marmot</a:t>
-                </a:r>
-              </a:p>
-              <a:p>
-                <a:r>
-                  <a:rPr lang="en-CA" sz="1400" b="0" i="1" dirty="0">
-                    <a:effectLst/>
-                    <a:latin typeface="Roboto Condensed" pitchFamily="2" charset="0"/>
-                    <a:ea typeface="Roboto Condensed" pitchFamily="2" charset="0"/>
-                  </a:rPr>
-                  <a:t>Marmota </a:t>
-                </a:r>
-                <a:r>
-                  <a:rPr lang="en-CA" sz="1400" b="0" i="1" dirty="0" err="1">
-                    <a:effectLst/>
-                    <a:latin typeface="Roboto Condensed" pitchFamily="2" charset="0"/>
-                    <a:ea typeface="Roboto Condensed" pitchFamily="2" charset="0"/>
-                  </a:rPr>
-                  <a:t>vancouverensis</a:t>
-                </a:r>
-                <a:endParaRPr lang="en-CA" sz="1400" b="0" i="1" dirty="0">
-                  <a:effectLst/>
-                  <a:latin typeface="Roboto Condensed" pitchFamily="2" charset="0"/>
-                  <a:ea typeface="Roboto Condensed" pitchFamily="2" charset="0"/>
-                </a:endParaRPr>
-              </a:p>
-            </p:txBody>
-          </p:sp>
-          <p:sp>
-            <p:nvSpPr>
-              <p:cNvPr id="19" name="TextBox 18">
-                <a:extLst>
-                  <a:ext uri="{FF2B5EF4-FFF2-40B4-BE49-F238E27FC236}">
-                    <a16:creationId xmlns:a16="http://schemas.microsoft.com/office/drawing/2014/main" id="{0AD1CB78-99F8-B3C5-4D9F-8123809D6ED5}"/>
-                  </a:ext>
-                </a:extLst>
-              </p:cNvPr>
-              <p:cNvSpPr txBox="1"/>
-              <p:nvPr/>
-            </p:nvSpPr>
-            <p:spPr>
-              <a:xfrm>
-                <a:off x="5625176" y="8362386"/>
-                <a:ext cx="4375748" cy="523220"/>
-              </a:xfrm>
-              <a:prstGeom prst="rect">
-                <a:avLst/>
-              </a:prstGeom>
-              <a:noFill/>
-            </p:spPr>
-            <p:txBody>
-              <a:bodyPr wrap="square" rtlCol="0">
-                <a:spAutoFit/>
-              </a:bodyPr>
-              <a:lstStyle>
-                <a:defPPr>
-                  <a:defRPr lang="en-US"/>
-                </a:defPPr>
-                <a:lvl1pPr>
-                  <a:defRPr sz="1600" b="0" i="0">
-                    <a:effectLst/>
-                    <a:latin typeface="Roboto Condensed" pitchFamily="2" charset="0"/>
-                    <a:ea typeface="Roboto Condensed" pitchFamily="2" charset="0"/>
-                  </a:defRPr>
-                </a:lvl1pPr>
-              </a:lstStyle>
-              <a:p>
-                <a:r>
-                  <a:rPr lang="en-CA" sz="1400" dirty="0"/>
-                  <a:t>California Tortoiseshell </a:t>
-                </a:r>
-              </a:p>
-              <a:p>
-                <a:r>
-                  <a:rPr lang="en-CA" sz="1400" i="1" dirty="0" err="1"/>
-                  <a:t>Nymphalis</a:t>
-                </a:r>
-                <a:r>
-                  <a:rPr lang="en-CA" sz="1400" i="1" dirty="0"/>
-                  <a:t> californica </a:t>
-                </a:r>
-              </a:p>
-            </p:txBody>
-          </p:sp>
-          <p:sp>
-            <p:nvSpPr>
-              <p:cNvPr id="21" name="TextBox 20">
-                <a:extLst>
-                  <a:ext uri="{FF2B5EF4-FFF2-40B4-BE49-F238E27FC236}">
-                    <a16:creationId xmlns:a16="http://schemas.microsoft.com/office/drawing/2014/main" id="{9C4BE664-A364-9531-31BD-DC727A1E40D4}"/>
-                  </a:ext>
-                </a:extLst>
-              </p:cNvPr>
-              <p:cNvSpPr txBox="1"/>
-              <p:nvPr/>
-            </p:nvSpPr>
-            <p:spPr>
-              <a:xfrm>
-                <a:off x="5619344" y="6816498"/>
-                <a:ext cx="2047644" cy="523220"/>
-              </a:xfrm>
-              <a:prstGeom prst="rect">
-                <a:avLst/>
-              </a:prstGeom>
-              <a:noFill/>
-            </p:spPr>
-            <p:txBody>
-              <a:bodyPr wrap="square" rtlCol="0">
-                <a:spAutoFit/>
-              </a:bodyPr>
-              <a:lstStyle>
-                <a:defPPr>
-                  <a:defRPr lang="en-US"/>
-                </a:defPPr>
-                <a:lvl1pPr>
-                  <a:defRPr sz="1600" b="0" i="0">
-                    <a:effectLst/>
-                    <a:latin typeface="Roboto Condensed" pitchFamily="2" charset="0"/>
-                    <a:ea typeface="Roboto Condensed" pitchFamily="2" charset="0"/>
-                  </a:defRPr>
-                </a:lvl1pPr>
-              </a:lstStyle>
-              <a:p>
-                <a:r>
-                  <a:rPr lang="en-CA" sz="1400" dirty="0"/>
-                  <a:t>Spring Salamander</a:t>
-                </a:r>
-              </a:p>
-              <a:p>
-                <a:r>
-                  <a:rPr lang="en-CA" sz="1400" i="1" dirty="0" err="1"/>
-                  <a:t>Gyrinophilus</a:t>
-                </a:r>
-                <a:r>
-                  <a:rPr lang="en-CA" sz="1400" i="1" dirty="0"/>
-                  <a:t> </a:t>
-                </a:r>
-                <a:r>
-                  <a:rPr lang="en-CA" sz="1400" i="1" dirty="0" err="1"/>
-                  <a:t>porphyriticus</a:t>
-                </a:r>
-                <a:endParaRPr lang="en-CA" sz="1400" i="1" dirty="0"/>
-              </a:p>
-            </p:txBody>
-          </p:sp>
-          <p:cxnSp>
-            <p:nvCxnSpPr>
-              <p:cNvPr id="23" name="Straight Arrow Connector 22">
-                <a:extLst>
-                  <a:ext uri="{FF2B5EF4-FFF2-40B4-BE49-F238E27FC236}">
-                    <a16:creationId xmlns:a16="http://schemas.microsoft.com/office/drawing/2014/main" id="{45B9CE47-56CC-2C60-26AB-144E4280EDC5}"/>
+                    <a16:creationId xmlns:a16="http://schemas.microsoft.com/office/drawing/2014/main" id="{CBD5E035-489D-8B33-9081-01A7C182C5E9}"/>
                   </a:ext>
                 </a:extLst>
               </p:cNvPr>
               <p:cNvCxnSpPr>
-                <a:cxnSpLocks/>
+                <a:stCxn id="7" idx="3"/>
               </p:cNvCxnSpPr>
               <p:nvPr/>
             </p:nvCxnSpPr>
             <p:spPr>
-              <a:xfrm flipH="1">
-                <a:off x="5245721" y="6465709"/>
-                <a:ext cx="427528" cy="0"/>
-              </a:xfrm>
-              <a:prstGeom prst="straightConnector1">
-                <a:avLst/>
-              </a:prstGeom>
-              <a:ln>
-                <a:tailEnd type="triangle"/>
-              </a:ln>
-            </p:spPr>
-            <p:style>
-              <a:lnRef idx="2">
-                <a:schemeClr val="dk1"/>
-              </a:lnRef>
-              <a:fillRef idx="0">
-                <a:schemeClr val="dk1"/>
-              </a:fillRef>
-              <a:effectRef idx="1">
-                <a:schemeClr val="dk1"/>
-              </a:effectRef>
-              <a:fontRef idx="minor">
-                <a:schemeClr val="tx1"/>
-              </a:fontRef>
-            </p:style>
-          </p:cxnSp>
-          <p:cxnSp>
-            <p:nvCxnSpPr>
-              <p:cNvPr id="29" name="Straight Arrow Connector 28">
-                <a:extLst>
-                  <a:ext uri="{FF2B5EF4-FFF2-40B4-BE49-F238E27FC236}">
-                    <a16:creationId xmlns:a16="http://schemas.microsoft.com/office/drawing/2014/main" id="{90A4AC86-EB25-6703-90AC-C37179117492}"/>
-                  </a:ext>
-                </a:extLst>
-              </p:cNvPr>
-              <p:cNvCxnSpPr>
-                <a:cxnSpLocks/>
-              </p:cNvCxnSpPr>
-              <p:nvPr/>
-            </p:nvCxnSpPr>
-            <p:spPr>
-              <a:xfrm flipH="1">
-                <a:off x="7142922" y="8139166"/>
-                <a:ext cx="450542" cy="0"/>
-              </a:xfrm>
-              <a:prstGeom prst="straightConnector1">
-                <a:avLst/>
-              </a:prstGeom>
-              <a:ln>
-                <a:tailEnd type="triangle"/>
-              </a:ln>
-            </p:spPr>
-            <p:style>
-              <a:lnRef idx="2">
-                <a:schemeClr val="dk1"/>
-              </a:lnRef>
-              <a:fillRef idx="0">
-                <a:schemeClr val="dk1"/>
-              </a:fillRef>
-              <a:effectRef idx="1">
-                <a:schemeClr val="dk1"/>
-              </a:effectRef>
-              <a:fontRef idx="minor">
-                <a:schemeClr val="tx1"/>
-              </a:fontRef>
-            </p:style>
-          </p:cxnSp>
-          <p:cxnSp>
-            <p:nvCxnSpPr>
-              <p:cNvPr id="31" name="Straight Arrow Connector 30">
-                <a:extLst>
-                  <a:ext uri="{FF2B5EF4-FFF2-40B4-BE49-F238E27FC236}">
-                    <a16:creationId xmlns:a16="http://schemas.microsoft.com/office/drawing/2014/main" id="{073F7B2F-029D-5026-FB78-AB944170E82D}"/>
-                  </a:ext>
-                </a:extLst>
-              </p:cNvPr>
-              <p:cNvCxnSpPr>
-                <a:cxnSpLocks/>
-              </p:cNvCxnSpPr>
-              <p:nvPr/>
-            </p:nvCxnSpPr>
-            <p:spPr>
-              <a:xfrm flipH="1">
-                <a:off x="5192049" y="8584352"/>
-                <a:ext cx="454696" cy="0"/>
-              </a:xfrm>
-              <a:prstGeom prst="straightConnector1">
-                <a:avLst/>
-              </a:prstGeom>
-              <a:ln>
-                <a:tailEnd type="triangle"/>
-              </a:ln>
-            </p:spPr>
-            <p:style>
-              <a:lnRef idx="2">
-                <a:schemeClr val="dk1"/>
-              </a:lnRef>
-              <a:fillRef idx="0">
-                <a:schemeClr val="dk1"/>
-              </a:fillRef>
-              <a:effectRef idx="1">
-                <a:schemeClr val="dk1"/>
-              </a:effectRef>
-              <a:fontRef idx="minor">
-                <a:schemeClr val="tx1"/>
-              </a:fontRef>
-            </p:style>
-          </p:cxnSp>
-          <p:cxnSp>
-            <p:nvCxnSpPr>
-              <p:cNvPr id="32" name="Straight Arrow Connector 31">
-                <a:extLst>
-                  <a:ext uri="{FF2B5EF4-FFF2-40B4-BE49-F238E27FC236}">
-                    <a16:creationId xmlns:a16="http://schemas.microsoft.com/office/drawing/2014/main" id="{02B60A8A-2C31-8DA4-5D93-A408B0C9DE3F}"/>
-                  </a:ext>
-                </a:extLst>
-              </p:cNvPr>
-              <p:cNvCxnSpPr>
-                <a:cxnSpLocks/>
-              </p:cNvCxnSpPr>
-              <p:nvPr/>
-            </p:nvCxnSpPr>
-            <p:spPr>
-              <a:xfrm flipH="1">
-                <a:off x="5124382" y="7086059"/>
-                <a:ext cx="494962" cy="0"/>
+              <a:xfrm>
+                <a:off x="5124382" y="620888"/>
+                <a:ext cx="436775" cy="261610"/>
               </a:xfrm>
               <a:prstGeom prst="straightConnector1">
                 <a:avLst/>
@@ -3995,10 +4373,10 @@
           </p:cxnSp>
           <p:sp>
             <p:nvSpPr>
-              <p:cNvPr id="26" name="TextBox 25">
+              <p:cNvPr id="25" name="TextBox 24">
                 <a:extLst>
                   <a:ext uri="{FF2B5EF4-FFF2-40B4-BE49-F238E27FC236}">
-                    <a16:creationId xmlns:a16="http://schemas.microsoft.com/office/drawing/2014/main" id="{A87C2C98-34F5-3874-2356-D786060F0E3B}"/>
+                    <a16:creationId xmlns:a16="http://schemas.microsoft.com/office/drawing/2014/main" id="{385F2109-B299-01F3-EB68-9A5E874A7B7F}"/>
                   </a:ext>
                 </a:extLst>
               </p:cNvPr>
@@ -4007,8 +4385,8 @@
             </p:nvSpPr>
             <p:spPr>
               <a:xfrm>
-                <a:off x="1690822" y="6265654"/>
-                <a:ext cx="1718277" cy="369332"/>
+                <a:off x="8137689" y="3058973"/>
+                <a:ext cx="1731701" cy="523220"/>
               </a:xfrm>
               <a:prstGeom prst="rect">
                 <a:avLst/>
@@ -4019,256 +4397,96 @@
               <a:bodyPr wrap="square" rtlCol="0">
                 <a:spAutoFit/>
               </a:bodyPr>
-              <a:lstStyle>
-                <a:defPPr>
-                  <a:defRPr lang="en-US"/>
-                </a:defPPr>
-                <a:lvl1pPr>
-                  <a:defRPr sz="1600" b="0" i="0">
+              <a:lstStyle/>
+              <a:p>
+                <a:pPr algn="r"/>
+                <a:r>
+                  <a:rPr lang="en-CA" sz="1400" b="0" i="0" u="none" strike="noStrike" dirty="0">
+                    <a:solidFill>
+                      <a:srgbClr val="000000"/>
+                    </a:solidFill>
                     <a:effectLst/>
                     <a:latin typeface="Roboto Condensed" pitchFamily="2" charset="0"/>
                     <a:ea typeface="Roboto Condensed" pitchFamily="2" charset="0"/>
-                  </a:defRPr>
-                </a:lvl1pPr>
-              </a:lstStyle>
-              <a:p>
-                <a:pPr algn="r"/>
+                  </a:rPr>
+                  <a:t>CBA 2025 </a:t>
+                </a:r>
+                <a:br>
+                  <a:rPr lang="en-CA" sz="1400" b="0" i="0" u="none" strike="noStrike" dirty="0">
+                    <a:solidFill>
+                      <a:srgbClr val="000000"/>
+                    </a:solidFill>
+                    <a:effectLst/>
+                    <a:latin typeface="Roboto Condensed" pitchFamily="2" charset="0"/>
+                    <a:ea typeface="Roboto Condensed" pitchFamily="2" charset="0"/>
+                  </a:rPr>
+                </a:br>
                 <a:r>
-                  <a:rPr lang="en-CA" sz="1800" b="1" dirty="0"/>
-                  <a:t>Reptiles</a:t>
+                  <a:rPr lang="en-CA" sz="1400" b="0" i="0" u="none" strike="noStrike" dirty="0">
+                    <a:solidFill>
+                      <a:srgbClr val="000000"/>
+                    </a:solidFill>
+                    <a:effectLst/>
+                    <a:latin typeface="Roboto Condensed" pitchFamily="2" charset="0"/>
+                    <a:ea typeface="Roboto Condensed" pitchFamily="2" charset="0"/>
+                  </a:rPr>
+                  <a:t>Bioblitz</a:t>
                 </a:r>
-                <a:endParaRPr lang="en-CA" sz="1800" b="1" i="1" dirty="0"/>
+                <a:endParaRPr lang="en-CA" sz="1400" dirty="0">
+                  <a:latin typeface="Roboto Condensed" pitchFamily="2" charset="0"/>
+                  <a:ea typeface="Roboto Condensed" pitchFamily="2" charset="0"/>
+                </a:endParaRPr>
               </a:p>
             </p:txBody>
           </p:sp>
-          <p:sp>
-            <p:nvSpPr>
-              <p:cNvPr id="28" name="TextBox 27">
+          <p:cxnSp>
+            <p:nvCxnSpPr>
+              <p:cNvPr id="27" name="Straight Arrow Connector 26">
                 <a:extLst>
                   <a:ext uri="{FF2B5EF4-FFF2-40B4-BE49-F238E27FC236}">
-                    <a16:creationId xmlns:a16="http://schemas.microsoft.com/office/drawing/2014/main" id="{D54E7786-C9ED-F8AD-D29D-78F85E1F041F}"/>
+                    <a16:creationId xmlns:a16="http://schemas.microsoft.com/office/drawing/2014/main" id="{EE14568C-AEDB-4A4B-DC11-E1E495AF6C53}"/>
                   </a:ext>
                 </a:extLst>
               </p:cNvPr>
-              <p:cNvSpPr txBox="1"/>
+              <p:cNvCxnSpPr>
+                <a:cxnSpLocks/>
+              </p:cNvCxnSpPr>
               <p:nvPr/>
-            </p:nvSpPr>
+            </p:nvCxnSpPr>
             <p:spPr>
-              <a:xfrm>
-                <a:off x="1690822" y="6857368"/>
-                <a:ext cx="1718277" cy="369332"/>
+              <a:xfrm flipH="1">
+                <a:off x="9419939" y="3582193"/>
+                <a:ext cx="62986" cy="263298"/>
               </a:xfrm>
-              <a:prstGeom prst="rect">
+              <a:prstGeom prst="straightConnector1">
                 <a:avLst/>
               </a:prstGeom>
-              <a:noFill/>
+              <a:ln>
+                <a:tailEnd type="triangle"/>
+              </a:ln>
             </p:spPr>
-            <p:txBody>
-              <a:bodyPr wrap="square" rtlCol="0">
-                <a:spAutoFit/>
-              </a:bodyPr>
-              <a:lstStyle>
-                <a:defPPr>
-                  <a:defRPr lang="en-US"/>
-                </a:defPPr>
-                <a:lvl1pPr>
-                  <a:defRPr sz="1600" b="0" i="0">
-                    <a:effectLst/>
-                    <a:latin typeface="Roboto Condensed" pitchFamily="2" charset="0"/>
-                    <a:ea typeface="Roboto Condensed" pitchFamily="2" charset="0"/>
-                  </a:defRPr>
-                </a:lvl1pPr>
-              </a:lstStyle>
-              <a:p>
-                <a:pPr algn="r"/>
-                <a:r>
-                  <a:rPr lang="en-CA" sz="1800" b="1" dirty="0"/>
-                  <a:t>Amphibians</a:t>
-                </a:r>
-                <a:endParaRPr lang="en-CA" sz="1800" b="1" i="1" dirty="0"/>
-              </a:p>
-            </p:txBody>
-          </p:sp>
-          <p:sp>
-            <p:nvSpPr>
-              <p:cNvPr id="30" name="TextBox 29">
-                <a:extLst>
-                  <a:ext uri="{FF2B5EF4-FFF2-40B4-BE49-F238E27FC236}">
-                    <a16:creationId xmlns:a16="http://schemas.microsoft.com/office/drawing/2014/main" id="{A2A1A0C0-D5E6-1A77-4A3F-D0227C66F32D}"/>
-                  </a:ext>
-                </a:extLst>
-              </p:cNvPr>
-              <p:cNvSpPr txBox="1"/>
-              <p:nvPr/>
-            </p:nvSpPr>
-            <p:spPr>
-              <a:xfrm>
-                <a:off x="1690822" y="7398239"/>
-                <a:ext cx="1718277" cy="369332"/>
-              </a:xfrm>
-              <a:prstGeom prst="rect">
-                <a:avLst/>
-              </a:prstGeom>
-              <a:noFill/>
-            </p:spPr>
-            <p:txBody>
-              <a:bodyPr wrap="square" rtlCol="0">
-                <a:spAutoFit/>
-              </a:bodyPr>
-              <a:lstStyle>
-                <a:defPPr>
-                  <a:defRPr lang="en-US"/>
-                </a:defPPr>
-                <a:lvl1pPr>
-                  <a:defRPr sz="1600" b="0" i="0">
-                    <a:effectLst/>
-                    <a:latin typeface="Roboto Condensed" pitchFamily="2" charset="0"/>
-                    <a:ea typeface="Roboto Condensed" pitchFamily="2" charset="0"/>
-                  </a:defRPr>
-                </a:lvl1pPr>
-              </a:lstStyle>
-              <a:p>
-                <a:pPr algn="r"/>
-                <a:r>
-                  <a:rPr lang="en-CA" sz="1800" b="1" dirty="0"/>
-                  <a:t>Plants</a:t>
-                </a:r>
-                <a:endParaRPr lang="en-CA" sz="1800" b="1" i="1" dirty="0"/>
-              </a:p>
-            </p:txBody>
-          </p:sp>
-          <p:sp>
-            <p:nvSpPr>
-              <p:cNvPr id="33" name="TextBox 32">
-                <a:extLst>
-                  <a:ext uri="{FF2B5EF4-FFF2-40B4-BE49-F238E27FC236}">
-                    <a16:creationId xmlns:a16="http://schemas.microsoft.com/office/drawing/2014/main" id="{1C644551-AEA9-6C0A-0B54-81061AA14647}"/>
-                  </a:ext>
-                </a:extLst>
-              </p:cNvPr>
-              <p:cNvSpPr txBox="1"/>
-              <p:nvPr/>
-            </p:nvSpPr>
-            <p:spPr>
-              <a:xfrm>
-                <a:off x="1690822" y="7939111"/>
-                <a:ext cx="1718277" cy="369332"/>
-              </a:xfrm>
-              <a:prstGeom prst="rect">
-                <a:avLst/>
-              </a:prstGeom>
-              <a:noFill/>
-            </p:spPr>
-            <p:txBody>
-              <a:bodyPr wrap="square" rtlCol="0">
-                <a:spAutoFit/>
-              </a:bodyPr>
-              <a:lstStyle>
-                <a:defPPr>
-                  <a:defRPr lang="en-US"/>
-                </a:defPPr>
-                <a:lvl1pPr>
-                  <a:defRPr sz="1600" b="0" i="0">
-                    <a:effectLst/>
-                    <a:latin typeface="Roboto Condensed" pitchFamily="2" charset="0"/>
-                    <a:ea typeface="Roboto Condensed" pitchFamily="2" charset="0"/>
-                  </a:defRPr>
-                </a:lvl1pPr>
-              </a:lstStyle>
-              <a:p>
-                <a:pPr algn="r"/>
-                <a:r>
-                  <a:rPr lang="en-CA" sz="1800" b="1" dirty="0"/>
-                  <a:t>Mammals</a:t>
-                </a:r>
-                <a:endParaRPr lang="en-CA" sz="1800" b="1" i="1" dirty="0"/>
-              </a:p>
-            </p:txBody>
-          </p:sp>
-          <p:sp>
-            <p:nvSpPr>
-              <p:cNvPr id="34" name="TextBox 33">
-                <a:extLst>
-                  <a:ext uri="{FF2B5EF4-FFF2-40B4-BE49-F238E27FC236}">
-                    <a16:creationId xmlns:a16="http://schemas.microsoft.com/office/drawing/2014/main" id="{500919C0-92BA-00CD-29D8-653824E77EDB}"/>
-                  </a:ext>
-                </a:extLst>
-              </p:cNvPr>
-              <p:cNvSpPr txBox="1"/>
-              <p:nvPr/>
-            </p:nvSpPr>
-            <p:spPr>
-              <a:xfrm>
-                <a:off x="1680202" y="8479983"/>
-                <a:ext cx="1718277" cy="369332"/>
-              </a:xfrm>
-              <a:prstGeom prst="rect">
-                <a:avLst/>
-              </a:prstGeom>
-              <a:noFill/>
-            </p:spPr>
-            <p:txBody>
-              <a:bodyPr wrap="square" rtlCol="0">
-                <a:spAutoFit/>
-              </a:bodyPr>
-              <a:lstStyle>
-                <a:defPPr>
-                  <a:defRPr lang="en-US"/>
-                </a:defPPr>
-                <a:lvl1pPr>
-                  <a:defRPr sz="1600" b="0" i="0">
-                    <a:effectLst/>
-                    <a:latin typeface="Roboto Condensed" pitchFamily="2" charset="0"/>
-                    <a:ea typeface="Roboto Condensed" pitchFamily="2" charset="0"/>
-                  </a:defRPr>
-                </a:lvl1pPr>
-              </a:lstStyle>
-              <a:p>
-                <a:pPr algn="r"/>
-                <a:r>
-                  <a:rPr lang="en-CA" sz="1800" b="1" dirty="0"/>
-                  <a:t>Butterflies</a:t>
-                </a:r>
-                <a:endParaRPr lang="en-CA" sz="1800" b="1" i="1" dirty="0"/>
-              </a:p>
-            </p:txBody>
-          </p:sp>
+            <p:style>
+              <a:lnRef idx="2">
+                <a:schemeClr val="dk1"/>
+              </a:lnRef>
+              <a:fillRef idx="0">
+                <a:schemeClr val="dk1"/>
+              </a:fillRef>
+              <a:effectRef idx="1">
+                <a:schemeClr val="dk1"/>
+              </a:effectRef>
+              <a:fontRef idx="minor">
+                <a:schemeClr val="tx1"/>
+              </a:fontRef>
+            </p:style>
+          </p:cxnSp>
         </p:grpSp>
-        <p:pic>
-          <p:nvPicPr>
-            <p:cNvPr id="6" name="Picture 5" descr="A map of canada with different colored areas&#10;&#10;Description automatically generated">
+        <p:sp>
+          <p:nvSpPr>
+            <p:cNvPr id="2" name="TextBox 1">
               <a:extLst>
                 <a:ext uri="{FF2B5EF4-FFF2-40B4-BE49-F238E27FC236}">
-                  <a16:creationId xmlns:a16="http://schemas.microsoft.com/office/drawing/2014/main" id="{1097B08F-4974-89E2-BEB0-C2B3B9DF2F5A}"/>
-                </a:ext>
-              </a:extLst>
-            </p:cNvPr>
-            <p:cNvPicPr>
-              <a:picLocks noChangeAspect="1"/>
-            </p:cNvPicPr>
-            <p:nvPr/>
-          </p:nvPicPr>
-          <p:blipFill>
-            <a:blip r:embed="rId3"/>
-            <a:srcRect l="9343" t="4885" r="7997" b="8770"/>
-            <a:stretch/>
-          </p:blipFill>
-          <p:spPr>
-            <a:xfrm>
-              <a:off x="2621748" y="-942072"/>
-              <a:ext cx="6948503" cy="6844918"/>
-            </a:xfrm>
-            <a:prstGeom prst="rect">
-              <a:avLst/>
-            </a:prstGeom>
-          </p:spPr>
-        </p:pic>
-        <p:sp>
-          <p:nvSpPr>
-            <p:cNvPr id="7" name="TextBox 6">
-              <a:extLst>
-                <a:ext uri="{FF2B5EF4-FFF2-40B4-BE49-F238E27FC236}">
-                  <a16:creationId xmlns:a16="http://schemas.microsoft.com/office/drawing/2014/main" id="{2DDA9446-9E8A-A269-CB06-E4768CF2D279}"/>
+                  <a16:creationId xmlns:a16="http://schemas.microsoft.com/office/drawing/2014/main" id="{9B9F530F-1D3C-4C6A-C6A1-C9DDBA3C425C}"/>
                 </a:ext>
               </a:extLst>
             </p:cNvPr>
@@ -4277,8 +4495,8 @@
           </p:nvSpPr>
           <p:spPr>
             <a:xfrm>
-              <a:off x="3392681" y="359278"/>
-              <a:ext cx="1731701" cy="523220"/>
+              <a:off x="8036692" y="2443502"/>
+              <a:ext cx="1351571" cy="523220"/>
             </a:xfrm>
             <a:prstGeom prst="rect">
               <a:avLst/>
@@ -4301,7 +4519,7 @@
                   <a:latin typeface="Roboto Condensed" pitchFamily="2" charset="0"/>
                   <a:ea typeface="Roboto Condensed" pitchFamily="2" charset="0"/>
                 </a:rPr>
-                <a:t>Expedition Fiord Arctic Bioblitz</a:t>
+                <a:t>Limestone Barrens Bioblitz</a:t>
               </a:r>
               <a:endParaRPr lang="en-CA" sz="1400" dirty="0">
                 <a:latin typeface="Roboto Condensed" pitchFamily="2" charset="0"/>
@@ -4312,119 +4530,10 @@
         </p:sp>
         <p:cxnSp>
           <p:nvCxnSpPr>
-            <p:cNvPr id="24" name="Straight Arrow Connector 23">
+            <p:cNvPr id="4" name="Straight Arrow Connector 3">
               <a:extLst>
                 <a:ext uri="{FF2B5EF4-FFF2-40B4-BE49-F238E27FC236}">
-                  <a16:creationId xmlns:a16="http://schemas.microsoft.com/office/drawing/2014/main" id="{CBD5E035-489D-8B33-9081-01A7C182C5E9}"/>
-                </a:ext>
-              </a:extLst>
-            </p:cNvPr>
-            <p:cNvCxnSpPr>
-              <a:stCxn id="7" idx="3"/>
-            </p:cNvCxnSpPr>
-            <p:nvPr/>
-          </p:nvCxnSpPr>
-          <p:spPr>
-            <a:xfrm>
-              <a:off x="5124382" y="620888"/>
-              <a:ext cx="436775" cy="261610"/>
-            </a:xfrm>
-            <a:prstGeom prst="straightConnector1">
-              <a:avLst/>
-            </a:prstGeom>
-            <a:ln>
-              <a:tailEnd type="triangle"/>
-            </a:ln>
-          </p:spPr>
-          <p:style>
-            <a:lnRef idx="2">
-              <a:schemeClr val="dk1"/>
-            </a:lnRef>
-            <a:fillRef idx="0">
-              <a:schemeClr val="dk1"/>
-            </a:fillRef>
-            <a:effectRef idx="1">
-              <a:schemeClr val="dk1"/>
-            </a:effectRef>
-            <a:fontRef idx="minor">
-              <a:schemeClr val="tx1"/>
-            </a:fontRef>
-          </p:style>
-        </p:cxnSp>
-        <p:sp>
-          <p:nvSpPr>
-            <p:cNvPr id="25" name="TextBox 24">
-              <a:extLst>
-                <a:ext uri="{FF2B5EF4-FFF2-40B4-BE49-F238E27FC236}">
-                  <a16:creationId xmlns:a16="http://schemas.microsoft.com/office/drawing/2014/main" id="{385F2109-B299-01F3-EB68-9A5E874A7B7F}"/>
-                </a:ext>
-              </a:extLst>
-            </p:cNvPr>
-            <p:cNvSpPr txBox="1"/>
-            <p:nvPr/>
-          </p:nvSpPr>
-          <p:spPr>
-            <a:xfrm>
-              <a:off x="8137689" y="3058973"/>
-              <a:ext cx="1731701" cy="523220"/>
-            </a:xfrm>
-            <a:prstGeom prst="rect">
-              <a:avLst/>
-            </a:prstGeom>
-            <a:noFill/>
-          </p:spPr>
-          <p:txBody>
-            <a:bodyPr wrap="square" rtlCol="0">
-              <a:spAutoFit/>
-            </a:bodyPr>
-            <a:lstStyle/>
-            <a:p>
-              <a:pPr algn="r"/>
-              <a:r>
-                <a:rPr lang="en-CA" sz="1400" b="0" i="0" u="none" strike="noStrike" dirty="0">
-                  <a:solidFill>
-                    <a:srgbClr val="000000"/>
-                  </a:solidFill>
-                  <a:effectLst/>
-                  <a:latin typeface="Roboto Condensed" pitchFamily="2" charset="0"/>
-                  <a:ea typeface="Roboto Condensed" pitchFamily="2" charset="0"/>
-                </a:rPr>
-                <a:t>CBA 2025 </a:t>
-              </a:r>
-              <a:br>
-                <a:rPr lang="en-CA" sz="1400" b="0" i="0" u="none" strike="noStrike" dirty="0">
-                  <a:solidFill>
-                    <a:srgbClr val="000000"/>
-                  </a:solidFill>
-                  <a:effectLst/>
-                  <a:latin typeface="Roboto Condensed" pitchFamily="2" charset="0"/>
-                  <a:ea typeface="Roboto Condensed" pitchFamily="2" charset="0"/>
-                </a:rPr>
-              </a:br>
-              <a:r>
-                <a:rPr lang="en-CA" sz="1400" b="0" i="0" u="none" strike="noStrike" dirty="0">
-                  <a:solidFill>
-                    <a:srgbClr val="000000"/>
-                  </a:solidFill>
-                  <a:effectLst/>
-                  <a:latin typeface="Roboto Condensed" pitchFamily="2" charset="0"/>
-                  <a:ea typeface="Roboto Condensed" pitchFamily="2" charset="0"/>
-                </a:rPr>
-                <a:t>Bioblitz</a:t>
-              </a:r>
-              <a:endParaRPr lang="en-CA" sz="1400" dirty="0">
-                <a:latin typeface="Roboto Condensed" pitchFamily="2" charset="0"/>
-                <a:ea typeface="Roboto Condensed" pitchFamily="2" charset="0"/>
-              </a:endParaRPr>
-            </a:p>
-          </p:txBody>
-        </p:sp>
-        <p:cxnSp>
-          <p:nvCxnSpPr>
-            <p:cNvPr id="27" name="Straight Arrow Connector 26">
-              <a:extLst>
-                <a:ext uri="{FF2B5EF4-FFF2-40B4-BE49-F238E27FC236}">
-                  <a16:creationId xmlns:a16="http://schemas.microsoft.com/office/drawing/2014/main" id="{EE14568C-AEDB-4A4B-DC11-E1E495AF6C53}"/>
+                  <a16:creationId xmlns:a16="http://schemas.microsoft.com/office/drawing/2014/main" id="{474DFEC1-853A-374C-FD5E-8E7381D0ADB1}"/>
                 </a:ext>
               </a:extLst>
             </p:cNvPr>
@@ -4435,8 +4544,8 @@
           </p:nvCxnSpPr>
           <p:spPr>
             <a:xfrm flipH="1">
-              <a:off x="9419939" y="3582193"/>
-              <a:ext cx="62986" cy="263298"/>
+              <a:off x="8888896" y="2933722"/>
+              <a:ext cx="173268" cy="651352"/>
             </a:xfrm>
             <a:prstGeom prst="straightConnector1">
               <a:avLst/>

</xml_diff>

<commit_message>
finalise the BTG results version
</commit_message>
<xml_diff>
--- a/figures/manual-edits/manual-rangecoverage.pptx
+++ b/figures/manual-edits/manual-rangecoverage.pptx
@@ -4,8 +4,12 @@
   <p:sldMasterIdLst>
     <p:sldMasterId id="2147483648" r:id="rId1"/>
   </p:sldMasterIdLst>
+  <p:notesMasterIdLst>
+    <p:notesMasterId r:id="rId4"/>
+  </p:notesMasterIdLst>
   <p:sldIdLst>
     <p:sldId id="257" r:id="rId2"/>
+    <p:sldId id="258" r:id="rId3"/>
   </p:sldIdLst>
   <p:sldSz cx="12192000" cy="6858000"/>
   <p:notesSz cx="6858000" cy="9144000"/>
@@ -112,6 +116,560 @@
 </p:presentation>
 </file>
 
+<file path=ppt/notesMasters/notesMaster1.xml><?xml version="1.0" encoding="utf-8"?>
+<p:notesMaster xmlns:a="http://schemas.openxmlformats.org/drawingml/2006/main" xmlns:r="http://schemas.openxmlformats.org/officeDocument/2006/relationships" xmlns:p="http://schemas.openxmlformats.org/presentationml/2006/main">
+  <p:cSld>
+    <p:bg>
+      <p:bgRef idx="1001">
+        <a:schemeClr val="bg1"/>
+      </p:bgRef>
+    </p:bg>
+    <p:spTree>
+      <p:nvGrpSpPr>
+        <p:cNvPr id="1" name=""/>
+        <p:cNvGrpSpPr/>
+        <p:nvPr/>
+      </p:nvGrpSpPr>
+      <p:grpSpPr>
+        <a:xfrm>
+          <a:off x="0" y="0"/>
+          <a:ext cx="0" cy="0"/>
+          <a:chOff x="0" y="0"/>
+          <a:chExt cx="0" cy="0"/>
+        </a:xfrm>
+      </p:grpSpPr>
+      <p:sp>
+        <p:nvSpPr>
+          <p:cNvPr id="2" name="Header Placeholder 1"/>
+          <p:cNvSpPr>
+            <a:spLocks noGrp="1"/>
+          </p:cNvSpPr>
+          <p:nvPr>
+            <p:ph type="hdr" sz="quarter"/>
+          </p:nvPr>
+        </p:nvSpPr>
+        <p:spPr>
+          <a:xfrm>
+            <a:off x="0" y="0"/>
+            <a:ext cx="2971800" cy="458788"/>
+          </a:xfrm>
+          <a:prstGeom prst="rect">
+            <a:avLst/>
+          </a:prstGeom>
+        </p:spPr>
+        <p:txBody>
+          <a:bodyPr vert="horz" lIns="91440" tIns="45720" rIns="91440" bIns="45720" rtlCol="0"/>
+          <a:lstStyle>
+            <a:lvl1pPr algn="l">
+              <a:defRPr sz="1200"/>
+            </a:lvl1pPr>
+          </a:lstStyle>
+          <a:p>
+            <a:endParaRPr lang="en-CA"/>
+          </a:p>
+        </p:txBody>
+      </p:sp>
+      <p:sp>
+        <p:nvSpPr>
+          <p:cNvPr id="3" name="Date Placeholder 2"/>
+          <p:cNvSpPr>
+            <a:spLocks noGrp="1"/>
+          </p:cNvSpPr>
+          <p:nvPr>
+            <p:ph type="dt" idx="1"/>
+          </p:nvPr>
+        </p:nvSpPr>
+        <p:spPr>
+          <a:xfrm>
+            <a:off x="3884613" y="0"/>
+            <a:ext cx="2971800" cy="458788"/>
+          </a:xfrm>
+          <a:prstGeom prst="rect">
+            <a:avLst/>
+          </a:prstGeom>
+        </p:spPr>
+        <p:txBody>
+          <a:bodyPr vert="horz" lIns="91440" tIns="45720" rIns="91440" bIns="45720" rtlCol="0"/>
+          <a:lstStyle>
+            <a:lvl1pPr algn="r">
+              <a:defRPr sz="1200"/>
+            </a:lvl1pPr>
+          </a:lstStyle>
+          <a:p>
+            <a:fld id="{F871B73E-213E-9043-B37D-404841900A69}" type="datetimeFigureOut">
+              <a:rPr lang="en-CA" smtClean="0"/>
+              <a:t>2026-05-25</a:t>
+            </a:fld>
+            <a:endParaRPr lang="en-CA"/>
+          </a:p>
+        </p:txBody>
+      </p:sp>
+      <p:sp>
+        <p:nvSpPr>
+          <p:cNvPr id="4" name="Slide Image Placeholder 3"/>
+          <p:cNvSpPr>
+            <a:spLocks noGrp="1" noRot="1" noChangeAspect="1"/>
+          </p:cNvSpPr>
+          <p:nvPr>
+            <p:ph type="sldImg" idx="2"/>
+          </p:nvPr>
+        </p:nvSpPr>
+        <p:spPr>
+          <a:xfrm>
+            <a:off x="685800" y="1143000"/>
+            <a:ext cx="5486400" cy="3086100"/>
+          </a:xfrm>
+          <a:prstGeom prst="rect">
+            <a:avLst/>
+          </a:prstGeom>
+          <a:noFill/>
+          <a:ln w="12700">
+            <a:solidFill>
+              <a:prstClr val="black"/>
+            </a:solidFill>
+          </a:ln>
+        </p:spPr>
+        <p:txBody>
+          <a:bodyPr vert="horz" lIns="91440" tIns="45720" rIns="91440" bIns="45720" rtlCol="0" anchor="ctr"/>
+          <a:lstStyle/>
+          <a:p>
+            <a:endParaRPr lang="en-CA"/>
+          </a:p>
+        </p:txBody>
+      </p:sp>
+      <p:sp>
+        <p:nvSpPr>
+          <p:cNvPr id="5" name="Notes Placeholder 4"/>
+          <p:cNvSpPr>
+            <a:spLocks noGrp="1"/>
+          </p:cNvSpPr>
+          <p:nvPr>
+            <p:ph type="body" sz="quarter" idx="3"/>
+          </p:nvPr>
+        </p:nvSpPr>
+        <p:spPr>
+          <a:xfrm>
+            <a:off x="685800" y="4400550"/>
+            <a:ext cx="5486400" cy="3600450"/>
+          </a:xfrm>
+          <a:prstGeom prst="rect">
+            <a:avLst/>
+          </a:prstGeom>
+        </p:spPr>
+        <p:txBody>
+          <a:bodyPr vert="horz" lIns="91440" tIns="45720" rIns="91440" bIns="45720" rtlCol="0"/>
+          <a:lstStyle/>
+          <a:p>
+            <a:pPr lvl="0"/>
+            <a:r>
+              <a:rPr lang="en-US"/>
+              <a:t>Click to edit Master text styles</a:t>
+            </a:r>
+          </a:p>
+          <a:p>
+            <a:pPr lvl="1"/>
+            <a:r>
+              <a:rPr lang="en-US"/>
+              <a:t>Second level</a:t>
+            </a:r>
+          </a:p>
+          <a:p>
+            <a:pPr lvl="2"/>
+            <a:r>
+              <a:rPr lang="en-US"/>
+              <a:t>Third level</a:t>
+            </a:r>
+          </a:p>
+          <a:p>
+            <a:pPr lvl="3"/>
+            <a:r>
+              <a:rPr lang="en-US"/>
+              <a:t>Fourth level</a:t>
+            </a:r>
+          </a:p>
+          <a:p>
+            <a:pPr lvl="4"/>
+            <a:r>
+              <a:rPr lang="en-US"/>
+              <a:t>Fifth level</a:t>
+            </a:r>
+            <a:endParaRPr lang="en-CA"/>
+          </a:p>
+        </p:txBody>
+      </p:sp>
+      <p:sp>
+        <p:nvSpPr>
+          <p:cNvPr id="6" name="Footer Placeholder 5"/>
+          <p:cNvSpPr>
+            <a:spLocks noGrp="1"/>
+          </p:cNvSpPr>
+          <p:nvPr>
+            <p:ph type="ftr" sz="quarter" idx="4"/>
+          </p:nvPr>
+        </p:nvSpPr>
+        <p:spPr>
+          <a:xfrm>
+            <a:off x="0" y="8685213"/>
+            <a:ext cx="2971800" cy="458787"/>
+          </a:xfrm>
+          <a:prstGeom prst="rect">
+            <a:avLst/>
+          </a:prstGeom>
+        </p:spPr>
+        <p:txBody>
+          <a:bodyPr vert="horz" lIns="91440" tIns="45720" rIns="91440" bIns="45720" rtlCol="0" anchor="b"/>
+          <a:lstStyle>
+            <a:lvl1pPr algn="l">
+              <a:defRPr sz="1200"/>
+            </a:lvl1pPr>
+          </a:lstStyle>
+          <a:p>
+            <a:endParaRPr lang="en-CA"/>
+          </a:p>
+        </p:txBody>
+      </p:sp>
+      <p:sp>
+        <p:nvSpPr>
+          <p:cNvPr id="7" name="Slide Number Placeholder 6"/>
+          <p:cNvSpPr>
+            <a:spLocks noGrp="1"/>
+          </p:cNvSpPr>
+          <p:nvPr>
+            <p:ph type="sldNum" sz="quarter" idx="5"/>
+          </p:nvPr>
+        </p:nvSpPr>
+        <p:spPr>
+          <a:xfrm>
+            <a:off x="3884613" y="8685213"/>
+            <a:ext cx="2971800" cy="458787"/>
+          </a:xfrm>
+          <a:prstGeom prst="rect">
+            <a:avLst/>
+          </a:prstGeom>
+        </p:spPr>
+        <p:txBody>
+          <a:bodyPr vert="horz" lIns="91440" tIns="45720" rIns="91440" bIns="45720" rtlCol="0" anchor="b"/>
+          <a:lstStyle>
+            <a:lvl1pPr algn="r">
+              <a:defRPr sz="1200"/>
+            </a:lvl1pPr>
+          </a:lstStyle>
+          <a:p>
+            <a:fld id="{1CE3BB95-3D93-5B4C-9AA7-36110F39E161}" type="slidenum">
+              <a:rPr lang="en-CA" smtClean="0"/>
+              <a:t>‹#›</a:t>
+            </a:fld>
+            <a:endParaRPr lang="en-CA"/>
+          </a:p>
+        </p:txBody>
+      </p:sp>
+    </p:spTree>
+    <p:extLst>
+      <p:ext uri="{BB962C8B-B14F-4D97-AF65-F5344CB8AC3E}">
+        <p14:creationId xmlns:p14="http://schemas.microsoft.com/office/powerpoint/2010/main" val="1396365011"/>
+      </p:ext>
+    </p:extLst>
+  </p:cSld>
+  <p:clrMap bg1="lt1" tx1="dk1" bg2="lt2" tx2="dk2" accent1="accent1" accent2="accent2" accent3="accent3" accent4="accent4" accent5="accent5" accent6="accent6" hlink="hlink" folHlink="folHlink"/>
+  <p:notesStyle>
+    <a:lvl1pPr marL="0" algn="l" defTabSz="914400" rtl="0" eaLnBrk="1" latinLnBrk="0" hangingPunct="1">
+      <a:defRPr sz="1200" kern="1200">
+        <a:solidFill>
+          <a:schemeClr val="tx1"/>
+        </a:solidFill>
+        <a:latin typeface="+mn-lt"/>
+        <a:ea typeface="+mn-ea"/>
+        <a:cs typeface="+mn-cs"/>
+      </a:defRPr>
+    </a:lvl1pPr>
+    <a:lvl2pPr marL="457200" algn="l" defTabSz="914400" rtl="0" eaLnBrk="1" latinLnBrk="0" hangingPunct="1">
+      <a:defRPr sz="1200" kern="1200">
+        <a:solidFill>
+          <a:schemeClr val="tx1"/>
+        </a:solidFill>
+        <a:latin typeface="+mn-lt"/>
+        <a:ea typeface="+mn-ea"/>
+        <a:cs typeface="+mn-cs"/>
+      </a:defRPr>
+    </a:lvl2pPr>
+    <a:lvl3pPr marL="914400" algn="l" defTabSz="914400" rtl="0" eaLnBrk="1" latinLnBrk="0" hangingPunct="1">
+      <a:defRPr sz="1200" kern="1200">
+        <a:solidFill>
+          <a:schemeClr val="tx1"/>
+        </a:solidFill>
+        <a:latin typeface="+mn-lt"/>
+        <a:ea typeface="+mn-ea"/>
+        <a:cs typeface="+mn-cs"/>
+      </a:defRPr>
+    </a:lvl3pPr>
+    <a:lvl4pPr marL="1371600" algn="l" defTabSz="914400" rtl="0" eaLnBrk="1" latinLnBrk="0" hangingPunct="1">
+      <a:defRPr sz="1200" kern="1200">
+        <a:solidFill>
+          <a:schemeClr val="tx1"/>
+        </a:solidFill>
+        <a:latin typeface="+mn-lt"/>
+        <a:ea typeface="+mn-ea"/>
+        <a:cs typeface="+mn-cs"/>
+      </a:defRPr>
+    </a:lvl4pPr>
+    <a:lvl5pPr marL="1828800" algn="l" defTabSz="914400" rtl="0" eaLnBrk="1" latinLnBrk="0" hangingPunct="1">
+      <a:defRPr sz="1200" kern="1200">
+        <a:solidFill>
+          <a:schemeClr val="tx1"/>
+        </a:solidFill>
+        <a:latin typeface="+mn-lt"/>
+        <a:ea typeface="+mn-ea"/>
+        <a:cs typeface="+mn-cs"/>
+      </a:defRPr>
+    </a:lvl5pPr>
+    <a:lvl6pPr marL="2286000" algn="l" defTabSz="914400" rtl="0" eaLnBrk="1" latinLnBrk="0" hangingPunct="1">
+      <a:defRPr sz="1200" kern="1200">
+        <a:solidFill>
+          <a:schemeClr val="tx1"/>
+        </a:solidFill>
+        <a:latin typeface="+mn-lt"/>
+        <a:ea typeface="+mn-ea"/>
+        <a:cs typeface="+mn-cs"/>
+      </a:defRPr>
+    </a:lvl6pPr>
+    <a:lvl7pPr marL="2743200" algn="l" defTabSz="914400" rtl="0" eaLnBrk="1" latinLnBrk="0" hangingPunct="1">
+      <a:defRPr sz="1200" kern="1200">
+        <a:solidFill>
+          <a:schemeClr val="tx1"/>
+        </a:solidFill>
+        <a:latin typeface="+mn-lt"/>
+        <a:ea typeface="+mn-ea"/>
+        <a:cs typeface="+mn-cs"/>
+      </a:defRPr>
+    </a:lvl7pPr>
+    <a:lvl8pPr marL="3200400" algn="l" defTabSz="914400" rtl="0" eaLnBrk="1" latinLnBrk="0" hangingPunct="1">
+      <a:defRPr sz="1200" kern="1200">
+        <a:solidFill>
+          <a:schemeClr val="tx1"/>
+        </a:solidFill>
+        <a:latin typeface="+mn-lt"/>
+        <a:ea typeface="+mn-ea"/>
+        <a:cs typeface="+mn-cs"/>
+      </a:defRPr>
+    </a:lvl8pPr>
+    <a:lvl9pPr marL="3657600" algn="l" defTabSz="914400" rtl="0" eaLnBrk="1" latinLnBrk="0" hangingPunct="1">
+      <a:defRPr sz="1200" kern="1200">
+        <a:solidFill>
+          <a:schemeClr val="tx1"/>
+        </a:solidFill>
+        <a:latin typeface="+mn-lt"/>
+        <a:ea typeface="+mn-ea"/>
+        <a:cs typeface="+mn-cs"/>
+      </a:defRPr>
+    </a:lvl9pPr>
+  </p:notesStyle>
+</p:notesMaster>
+</file>
+
+<file path=ppt/notesSlides/notesSlide1.xml><?xml version="1.0" encoding="utf-8"?>
+<p:notes xmlns:a="http://schemas.openxmlformats.org/drawingml/2006/main" xmlns:r="http://schemas.openxmlformats.org/officeDocument/2006/relationships" xmlns:p="http://schemas.openxmlformats.org/presentationml/2006/main">
+  <p:cSld>
+    <p:spTree>
+      <p:nvGrpSpPr>
+        <p:cNvPr id="1" name=""/>
+        <p:cNvGrpSpPr/>
+        <p:nvPr/>
+      </p:nvGrpSpPr>
+      <p:grpSpPr>
+        <a:xfrm>
+          <a:off x="0" y="0"/>
+          <a:ext cx="0" cy="0"/>
+          <a:chOff x="0" y="0"/>
+          <a:chExt cx="0" cy="0"/>
+        </a:xfrm>
+      </p:grpSpPr>
+      <p:sp>
+        <p:nvSpPr>
+          <p:cNvPr id="2" name="Slide Image Placeholder 1"/>
+          <p:cNvSpPr>
+            <a:spLocks noGrp="1" noRot="1" noChangeAspect="1"/>
+          </p:cNvSpPr>
+          <p:nvPr>
+            <p:ph type="sldImg"/>
+          </p:nvPr>
+        </p:nvSpPr>
+        <p:spPr/>
+      </p:sp>
+      <p:sp>
+        <p:nvSpPr>
+          <p:cNvPr id="3" name="Notes Placeholder 2"/>
+          <p:cNvSpPr>
+            <a:spLocks noGrp="1"/>
+          </p:cNvSpPr>
+          <p:nvPr>
+            <p:ph type="body" idx="1"/>
+          </p:nvPr>
+        </p:nvSpPr>
+        <p:spPr/>
+        <p:txBody>
+          <a:bodyPr/>
+          <a:lstStyle/>
+          <a:p>
+            <a:r>
+              <a:rPr lang="en-CA" dirty="0"/>
+              <a:t>Full 2025 version</a:t>
+            </a:r>
+          </a:p>
+          <a:p>
+            <a:endParaRPr lang="en-CA" dirty="0"/>
+          </a:p>
+        </p:txBody>
+      </p:sp>
+      <p:sp>
+        <p:nvSpPr>
+          <p:cNvPr id="4" name="Slide Number Placeholder 3"/>
+          <p:cNvSpPr>
+            <a:spLocks noGrp="1"/>
+          </p:cNvSpPr>
+          <p:nvPr>
+            <p:ph type="sldNum" sz="quarter" idx="5"/>
+          </p:nvPr>
+        </p:nvSpPr>
+        <p:spPr/>
+        <p:txBody>
+          <a:bodyPr/>
+          <a:lstStyle/>
+          <a:p>
+            <a:fld id="{1CE3BB95-3D93-5B4C-9AA7-36110F39E161}" type="slidenum">
+              <a:rPr lang="en-CA" smtClean="0"/>
+              <a:t>1</a:t>
+            </a:fld>
+            <a:endParaRPr lang="en-CA"/>
+          </a:p>
+        </p:txBody>
+      </p:sp>
+    </p:spTree>
+    <p:extLst>
+      <p:ext uri="{BB962C8B-B14F-4D97-AF65-F5344CB8AC3E}">
+        <p14:creationId xmlns:p14="http://schemas.microsoft.com/office/powerpoint/2010/main" val="3900905234"/>
+      </p:ext>
+    </p:extLst>
+  </p:cSld>
+  <p:clrMapOvr>
+    <a:masterClrMapping/>
+  </p:clrMapOvr>
+</p:notes>
+</file>
+
+<file path=ppt/notesSlides/notesSlide2.xml><?xml version="1.0" encoding="utf-8"?>
+<p:notes xmlns:a="http://schemas.openxmlformats.org/drawingml/2006/main" xmlns:r="http://schemas.openxmlformats.org/officeDocument/2006/relationships" xmlns:p="http://schemas.openxmlformats.org/presentationml/2006/main">
+  <p:cSld>
+    <p:spTree>
+      <p:nvGrpSpPr>
+        <p:cNvPr id="1" name="">
+          <a:extLst>
+            <a:ext uri="{FF2B5EF4-FFF2-40B4-BE49-F238E27FC236}">
+              <a16:creationId xmlns:a16="http://schemas.microsoft.com/office/drawing/2014/main" id="{ABC985F9-8CFE-2660-DD0D-709A1A67662B}"/>
+            </a:ext>
+          </a:extLst>
+        </p:cNvPr>
+        <p:cNvGrpSpPr/>
+        <p:nvPr/>
+      </p:nvGrpSpPr>
+      <p:grpSpPr>
+        <a:xfrm>
+          <a:off x="0" y="0"/>
+          <a:ext cx="0" cy="0"/>
+          <a:chOff x="0" y="0"/>
+          <a:chExt cx="0" cy="0"/>
+        </a:xfrm>
+      </p:grpSpPr>
+      <p:sp>
+        <p:nvSpPr>
+          <p:cNvPr id="2" name="Slide Image Placeholder 1">
+            <a:extLst>
+              <a:ext uri="{FF2B5EF4-FFF2-40B4-BE49-F238E27FC236}">
+                <a16:creationId xmlns:a16="http://schemas.microsoft.com/office/drawing/2014/main" id="{4C9A5763-9FB0-B24A-4955-70CD81F36604}"/>
+              </a:ext>
+            </a:extLst>
+          </p:cNvPr>
+          <p:cNvSpPr>
+            <a:spLocks noGrp="1" noRot="1" noChangeAspect="1"/>
+          </p:cNvSpPr>
+          <p:nvPr>
+            <p:ph type="sldImg"/>
+          </p:nvPr>
+        </p:nvSpPr>
+        <p:spPr/>
+      </p:sp>
+      <p:sp>
+        <p:nvSpPr>
+          <p:cNvPr id="3" name="Notes Placeholder 2">
+            <a:extLst>
+              <a:ext uri="{FF2B5EF4-FFF2-40B4-BE49-F238E27FC236}">
+                <a16:creationId xmlns:a16="http://schemas.microsoft.com/office/drawing/2014/main" id="{3193B383-B82B-2742-3E8D-9134D5D25AD6}"/>
+              </a:ext>
+            </a:extLst>
+          </p:cNvPr>
+          <p:cNvSpPr>
+            <a:spLocks noGrp="1"/>
+          </p:cNvSpPr>
+          <p:nvPr>
+            <p:ph type="body" idx="1"/>
+          </p:nvPr>
+        </p:nvSpPr>
+        <p:spPr/>
+        <p:txBody>
+          <a:bodyPr/>
+          <a:lstStyle/>
+          <a:p>
+            <a:r>
+              <a:rPr lang="en-CA" dirty="0"/>
+              <a:t>Full 2025 version</a:t>
+            </a:r>
+          </a:p>
+          <a:p>
+            <a:endParaRPr lang="en-CA" dirty="0"/>
+          </a:p>
+        </p:txBody>
+      </p:sp>
+      <p:sp>
+        <p:nvSpPr>
+          <p:cNvPr id="4" name="Slide Number Placeholder 3">
+            <a:extLst>
+              <a:ext uri="{FF2B5EF4-FFF2-40B4-BE49-F238E27FC236}">
+                <a16:creationId xmlns:a16="http://schemas.microsoft.com/office/drawing/2014/main" id="{15589CBE-CC8B-2531-6AD0-8F5E9F66E4C0}"/>
+              </a:ext>
+            </a:extLst>
+          </p:cNvPr>
+          <p:cNvSpPr>
+            <a:spLocks noGrp="1"/>
+          </p:cNvSpPr>
+          <p:nvPr>
+            <p:ph type="sldNum" sz="quarter" idx="5"/>
+          </p:nvPr>
+        </p:nvSpPr>
+        <p:spPr/>
+        <p:txBody>
+          <a:bodyPr/>
+          <a:lstStyle/>
+          <a:p>
+            <a:fld id="{1CE3BB95-3D93-5B4C-9AA7-36110F39E161}" type="slidenum">
+              <a:rPr lang="en-CA" smtClean="0"/>
+              <a:t>2</a:t>
+            </a:fld>
+            <a:endParaRPr lang="en-CA"/>
+          </a:p>
+        </p:txBody>
+      </p:sp>
+    </p:spTree>
+    <p:extLst>
+      <p:ext uri="{BB962C8B-B14F-4D97-AF65-F5344CB8AC3E}">
+        <p14:creationId xmlns:p14="http://schemas.microsoft.com/office/powerpoint/2010/main" val="3985364291"/>
+      </p:ext>
+    </p:extLst>
+  </p:cSld>
+  <p:clrMapOvr>
+    <a:masterClrMapping/>
+  </p:clrMapOvr>
+</p:notes>
+</file>
+
 <file path=ppt/slideLayouts/slideLayout1.xml><?xml version="1.0" encoding="utf-8"?>
 <p:sldLayout xmlns:a="http://schemas.openxmlformats.org/drawingml/2006/main" xmlns:r="http://schemas.openxmlformats.org/officeDocument/2006/relationships" xmlns:p="http://schemas.openxmlformats.org/presentationml/2006/main" type="title" preserve="1">
   <p:cSld name="Title Slide">
@@ -261,7 +819,7 @@
           <a:p>
             <a:fld id="{BE16F19D-6681-6141-A356-A6917F007572}" type="datetimeFigureOut">
               <a:rPr lang="en-CA" smtClean="0"/>
-              <a:t>2026-05-13</a:t>
+              <a:t>2026-05-25</a:t>
             </a:fld>
             <a:endParaRPr lang="en-CA"/>
           </a:p>
@@ -461,7 +1019,7 @@
           <a:p>
             <a:fld id="{BE16F19D-6681-6141-A356-A6917F007572}" type="datetimeFigureOut">
               <a:rPr lang="en-CA" smtClean="0"/>
-              <a:t>2026-05-13</a:t>
+              <a:t>2026-05-25</a:t>
             </a:fld>
             <a:endParaRPr lang="en-CA"/>
           </a:p>
@@ -671,7 +1229,7 @@
           <a:p>
             <a:fld id="{BE16F19D-6681-6141-A356-A6917F007572}" type="datetimeFigureOut">
               <a:rPr lang="en-CA" smtClean="0"/>
-              <a:t>2026-05-13</a:t>
+              <a:t>2026-05-25</a:t>
             </a:fld>
             <a:endParaRPr lang="en-CA"/>
           </a:p>
@@ -871,7 +1429,7 @@
           <a:p>
             <a:fld id="{BE16F19D-6681-6141-A356-A6917F007572}" type="datetimeFigureOut">
               <a:rPr lang="en-CA" smtClean="0"/>
-              <a:t>2026-05-13</a:t>
+              <a:t>2026-05-25</a:t>
             </a:fld>
             <a:endParaRPr lang="en-CA"/>
           </a:p>
@@ -1147,7 +1705,7 @@
           <a:p>
             <a:fld id="{BE16F19D-6681-6141-A356-A6917F007572}" type="datetimeFigureOut">
               <a:rPr lang="en-CA" smtClean="0"/>
-              <a:t>2026-05-13</a:t>
+              <a:t>2026-05-25</a:t>
             </a:fld>
             <a:endParaRPr lang="en-CA"/>
           </a:p>
@@ -1415,7 +1973,7 @@
           <a:p>
             <a:fld id="{BE16F19D-6681-6141-A356-A6917F007572}" type="datetimeFigureOut">
               <a:rPr lang="en-CA" smtClean="0"/>
-              <a:t>2026-05-13</a:t>
+              <a:t>2026-05-25</a:t>
             </a:fld>
             <a:endParaRPr lang="en-CA"/>
           </a:p>
@@ -1830,7 +2388,7 @@
           <a:p>
             <a:fld id="{BE16F19D-6681-6141-A356-A6917F007572}" type="datetimeFigureOut">
               <a:rPr lang="en-CA" smtClean="0"/>
-              <a:t>2026-05-13</a:t>
+              <a:t>2026-05-25</a:t>
             </a:fld>
             <a:endParaRPr lang="en-CA"/>
           </a:p>
@@ -1972,7 +2530,7 @@
           <a:p>
             <a:fld id="{BE16F19D-6681-6141-A356-A6917F007572}" type="datetimeFigureOut">
               <a:rPr lang="en-CA" smtClean="0"/>
-              <a:t>2026-05-13</a:t>
+              <a:t>2026-05-25</a:t>
             </a:fld>
             <a:endParaRPr lang="en-CA"/>
           </a:p>
@@ -2085,7 +2643,7 @@
           <a:p>
             <a:fld id="{BE16F19D-6681-6141-A356-A6917F007572}" type="datetimeFigureOut">
               <a:rPr lang="en-CA" smtClean="0"/>
-              <a:t>2026-05-13</a:t>
+              <a:t>2026-05-25</a:t>
             </a:fld>
             <a:endParaRPr lang="en-CA"/>
           </a:p>
@@ -2398,7 +2956,7 @@
           <a:p>
             <a:fld id="{BE16F19D-6681-6141-A356-A6917F007572}" type="datetimeFigureOut">
               <a:rPr lang="en-CA" smtClean="0"/>
-              <a:t>2026-05-13</a:t>
+              <a:t>2026-05-25</a:t>
             </a:fld>
             <a:endParaRPr lang="en-CA"/>
           </a:p>
@@ -2687,7 +3245,7 @@
           <a:p>
             <a:fld id="{BE16F19D-6681-6141-A356-A6917F007572}" type="datetimeFigureOut">
               <a:rPr lang="en-CA" smtClean="0"/>
-              <a:t>2026-05-13</a:t>
+              <a:t>2026-05-25</a:t>
             </a:fld>
             <a:endParaRPr lang="en-CA"/>
           </a:p>
@@ -2930,7 +3488,7 @@
           <a:p>
             <a:fld id="{BE16F19D-6681-6141-A356-A6917F007572}" type="datetimeFigureOut">
               <a:rPr lang="en-CA" smtClean="0"/>
-              <a:t>2026-05-13</a:t>
+              <a:t>2026-05-25</a:t>
             </a:fld>
             <a:endParaRPr lang="en-CA"/>
           </a:p>
@@ -3480,7 +4038,7 @@
                 <p:nvPr/>
               </p:nvPicPr>
               <p:blipFill>
-                <a:blip r:embed="rId2"/>
+                <a:blip r:embed="rId3"/>
                 <a:srcRect l="27530" b="7853"/>
                 <a:stretch/>
               </p:blipFill>
@@ -4269,7 +4827,7 @@
               <p:nvPr/>
             </p:nvPicPr>
             <p:blipFill>
-              <a:blip r:embed="rId3"/>
+              <a:blip r:embed="rId4"/>
               <a:srcRect l="9343" t="4885" r="7997" b="8770"/>
               <a:stretch/>
             </p:blipFill>
@@ -4574,6 +5132,1286 @@
     <p:extLst>
       <p:ext uri="{BB962C8B-B14F-4D97-AF65-F5344CB8AC3E}">
         <p14:creationId xmlns:p14="http://schemas.microsoft.com/office/powerpoint/2010/main" val="187246131"/>
+      </p:ext>
+    </p:extLst>
+  </p:cSld>
+  <p:clrMapOvr>
+    <a:masterClrMapping/>
+  </p:clrMapOvr>
+</p:sld>
+</file>
+
+<file path=ppt/slides/slide2.xml><?xml version="1.0" encoding="utf-8"?>
+<p:sld xmlns:a="http://schemas.openxmlformats.org/drawingml/2006/main" xmlns:r="http://schemas.openxmlformats.org/officeDocument/2006/relationships" xmlns:p="http://schemas.openxmlformats.org/presentationml/2006/main">
+  <p:cSld>
+    <p:spTree>
+      <p:nvGrpSpPr>
+        <p:cNvPr id="1" name="">
+          <a:extLst>
+            <a:ext uri="{FF2B5EF4-FFF2-40B4-BE49-F238E27FC236}">
+              <a16:creationId xmlns:a16="http://schemas.microsoft.com/office/drawing/2014/main" id="{2C8C5671-EABD-62E9-E3C1-986ECB138F2B}"/>
+            </a:ext>
+          </a:extLst>
+        </p:cNvPr>
+        <p:cNvGrpSpPr/>
+        <p:nvPr/>
+      </p:nvGrpSpPr>
+      <p:grpSpPr>
+        <a:xfrm>
+          <a:off x="0" y="0"/>
+          <a:ext cx="0" cy="0"/>
+          <a:chOff x="0" y="0"/>
+          <a:chExt cx="0" cy="0"/>
+        </a:xfrm>
+      </p:grpSpPr>
+      <p:grpSp>
+        <p:nvGrpSpPr>
+          <p:cNvPr id="47" name="Group 46">
+            <a:extLst>
+              <a:ext uri="{FF2B5EF4-FFF2-40B4-BE49-F238E27FC236}">
+                <a16:creationId xmlns:a16="http://schemas.microsoft.com/office/drawing/2014/main" id="{DF26E13C-E79E-D674-1B97-55617FF84F07}"/>
+              </a:ext>
+            </a:extLst>
+          </p:cNvPr>
+          <p:cNvGrpSpPr/>
+          <p:nvPr/>
+        </p:nvGrpSpPr>
+        <p:grpSpPr>
+          <a:xfrm>
+            <a:off x="1680202" y="-1332723"/>
+            <a:ext cx="8446969" cy="11320728"/>
+            <a:chOff x="1680202" y="-1332723"/>
+            <a:chExt cx="8446969" cy="11320728"/>
+          </a:xfrm>
+        </p:grpSpPr>
+        <p:sp>
+          <p:nvSpPr>
+            <p:cNvPr id="35" name="Rectangle 34">
+              <a:extLst>
+                <a:ext uri="{FF2B5EF4-FFF2-40B4-BE49-F238E27FC236}">
+                  <a16:creationId xmlns:a16="http://schemas.microsoft.com/office/drawing/2014/main" id="{7DD48302-36B7-54D3-8939-B0D083CAFD98}"/>
+                </a:ext>
+              </a:extLst>
+            </p:cNvPr>
+            <p:cNvSpPr/>
+            <p:nvPr/>
+          </p:nvSpPr>
+          <p:spPr>
+            <a:xfrm>
+              <a:off x="1922106" y="-1332723"/>
+              <a:ext cx="8078819" cy="11320728"/>
+            </a:xfrm>
+            <a:prstGeom prst="rect">
+              <a:avLst/>
+            </a:prstGeom>
+            <a:solidFill>
+              <a:schemeClr val="bg1"/>
+            </a:solidFill>
+            <a:ln>
+              <a:noFill/>
+            </a:ln>
+          </p:spPr>
+          <p:style>
+            <a:lnRef idx="2">
+              <a:schemeClr val="accent1">
+                <a:shade val="15000"/>
+              </a:schemeClr>
+            </a:lnRef>
+            <a:fillRef idx="1">
+              <a:schemeClr val="accent1"/>
+            </a:fillRef>
+            <a:effectRef idx="0">
+              <a:schemeClr val="accent1"/>
+            </a:effectRef>
+            <a:fontRef idx="minor">
+              <a:schemeClr val="lt1"/>
+            </a:fontRef>
+          </p:style>
+          <p:txBody>
+            <a:bodyPr rtlCol="0" anchor="ctr"/>
+            <a:lstStyle/>
+            <a:p>
+              <a:pPr algn="ctr"/>
+              <a:endParaRPr lang="en-CA"/>
+            </a:p>
+          </p:txBody>
+        </p:sp>
+        <p:pic>
+          <p:nvPicPr>
+            <p:cNvPr id="20" name="Picture 19" descr="A graph with different colored dots&#10;&#10;Description automatically generated">
+              <a:extLst>
+                <a:ext uri="{FF2B5EF4-FFF2-40B4-BE49-F238E27FC236}">
+                  <a16:creationId xmlns:a16="http://schemas.microsoft.com/office/drawing/2014/main" id="{500F0B1E-D292-8539-98B4-CE7322E8279E}"/>
+                </a:ext>
+              </a:extLst>
+            </p:cNvPr>
+            <p:cNvPicPr>
+              <a:picLocks noChangeAspect="1"/>
+            </p:cNvPicPr>
+            <p:nvPr/>
+          </p:nvPicPr>
+          <p:blipFill>
+            <a:blip r:embed="rId3"/>
+            <a:srcRect l="27434" b="9682"/>
+            <a:stretch/>
+          </p:blipFill>
+          <p:spPr>
+            <a:xfrm>
+              <a:off x="3425551" y="5546836"/>
+              <a:ext cx="6552406" cy="4325101"/>
+            </a:xfrm>
+            <a:prstGeom prst="rect">
+              <a:avLst/>
+            </a:prstGeom>
+          </p:spPr>
+        </p:pic>
+        <p:pic>
+          <p:nvPicPr>
+            <p:cNvPr id="45" name="Picture 44" descr="A map of canada with different colored spots&#10;&#10;Description automatically generated">
+              <a:extLst>
+                <a:ext uri="{FF2B5EF4-FFF2-40B4-BE49-F238E27FC236}">
+                  <a16:creationId xmlns:a16="http://schemas.microsoft.com/office/drawing/2014/main" id="{B78DA972-487A-3B66-39A4-32AB9D35B760}"/>
+                </a:ext>
+              </a:extLst>
+            </p:cNvPr>
+            <p:cNvPicPr>
+              <a:picLocks noChangeAspect="1"/>
+            </p:cNvPicPr>
+            <p:nvPr/>
+          </p:nvPicPr>
+          <p:blipFill>
+            <a:blip r:embed="rId4"/>
+            <a:srcRect l="10218" t="6495" r="8196" b="9005"/>
+            <a:stretch/>
+          </p:blipFill>
+          <p:spPr>
+            <a:xfrm>
+              <a:off x="2537370" y="-786435"/>
+              <a:ext cx="7046711" cy="6882764"/>
+            </a:xfrm>
+            <a:prstGeom prst="rect">
+              <a:avLst/>
+            </a:prstGeom>
+          </p:spPr>
+        </p:pic>
+        <p:sp>
+          <p:nvSpPr>
+            <p:cNvPr id="7" name="TextBox 6">
+              <a:extLst>
+                <a:ext uri="{FF2B5EF4-FFF2-40B4-BE49-F238E27FC236}">
+                  <a16:creationId xmlns:a16="http://schemas.microsoft.com/office/drawing/2014/main" id="{FED63A58-3E94-386D-7503-996B4854937D}"/>
+                </a:ext>
+              </a:extLst>
+            </p:cNvPr>
+            <p:cNvSpPr txBox="1"/>
+            <p:nvPr/>
+          </p:nvSpPr>
+          <p:spPr>
+            <a:xfrm>
+              <a:off x="3288261" y="184032"/>
+              <a:ext cx="1731701" cy="523220"/>
+            </a:xfrm>
+            <a:prstGeom prst="rect">
+              <a:avLst/>
+            </a:prstGeom>
+            <a:noFill/>
+          </p:spPr>
+          <p:txBody>
+            <a:bodyPr wrap="square" rtlCol="0">
+              <a:spAutoFit/>
+            </a:bodyPr>
+            <a:lstStyle/>
+            <a:p>
+              <a:pPr algn="r"/>
+              <a:r>
+                <a:rPr lang="en-CA" sz="1400" b="0" i="0" u="none" strike="noStrike" dirty="0">
+                  <a:solidFill>
+                    <a:srgbClr val="000000"/>
+                  </a:solidFill>
+                  <a:effectLst/>
+                  <a:latin typeface="Roboto Condensed" pitchFamily="2" charset="0"/>
+                  <a:ea typeface="Roboto Condensed" pitchFamily="2" charset="0"/>
+                </a:rPr>
+                <a:t>Expedition Fiord Arctic Bioblitz</a:t>
+              </a:r>
+              <a:endParaRPr lang="en-CA" sz="1400" dirty="0">
+                <a:latin typeface="Roboto Condensed" pitchFamily="2" charset="0"/>
+                <a:ea typeface="Roboto Condensed" pitchFamily="2" charset="0"/>
+              </a:endParaRPr>
+            </a:p>
+          </p:txBody>
+        </p:sp>
+        <p:cxnSp>
+          <p:nvCxnSpPr>
+            <p:cNvPr id="24" name="Straight Arrow Connector 23">
+              <a:extLst>
+                <a:ext uri="{FF2B5EF4-FFF2-40B4-BE49-F238E27FC236}">
+                  <a16:creationId xmlns:a16="http://schemas.microsoft.com/office/drawing/2014/main" id="{24CA986C-7BA9-EE42-A245-E4211D05A09F}"/>
+                </a:ext>
+              </a:extLst>
+            </p:cNvPr>
+            <p:cNvCxnSpPr>
+              <a:cxnSpLocks/>
+            </p:cNvCxnSpPr>
+            <p:nvPr/>
+          </p:nvCxnSpPr>
+          <p:spPr>
+            <a:xfrm>
+              <a:off x="5015786" y="627860"/>
+              <a:ext cx="436775" cy="261610"/>
+            </a:xfrm>
+            <a:prstGeom prst="straightConnector1">
+              <a:avLst/>
+            </a:prstGeom>
+            <a:ln>
+              <a:tailEnd type="triangle"/>
+            </a:ln>
+          </p:spPr>
+          <p:style>
+            <a:lnRef idx="2">
+              <a:schemeClr val="dk1"/>
+            </a:lnRef>
+            <a:fillRef idx="0">
+              <a:schemeClr val="dk1"/>
+            </a:fillRef>
+            <a:effectRef idx="1">
+              <a:schemeClr val="dk1"/>
+            </a:effectRef>
+            <a:fontRef idx="minor">
+              <a:schemeClr val="tx1"/>
+            </a:fontRef>
+          </p:style>
+        </p:cxnSp>
+        <p:sp>
+          <p:nvSpPr>
+            <p:cNvPr id="25" name="TextBox 24">
+              <a:extLst>
+                <a:ext uri="{FF2B5EF4-FFF2-40B4-BE49-F238E27FC236}">
+                  <a16:creationId xmlns:a16="http://schemas.microsoft.com/office/drawing/2014/main" id="{8DAFA0C7-8BCB-7344-A375-AB0B4362F98F}"/>
+                </a:ext>
+              </a:extLst>
+            </p:cNvPr>
+            <p:cNvSpPr txBox="1"/>
+            <p:nvPr/>
+          </p:nvSpPr>
+          <p:spPr>
+            <a:xfrm>
+              <a:off x="8186205" y="3169949"/>
+              <a:ext cx="1731701" cy="523220"/>
+            </a:xfrm>
+            <a:prstGeom prst="rect">
+              <a:avLst/>
+            </a:prstGeom>
+            <a:noFill/>
+          </p:spPr>
+          <p:txBody>
+            <a:bodyPr wrap="square" rtlCol="0">
+              <a:spAutoFit/>
+            </a:bodyPr>
+            <a:lstStyle/>
+            <a:p>
+              <a:pPr algn="r"/>
+              <a:r>
+                <a:rPr lang="en-CA" sz="1400" b="0" i="0" u="none" strike="noStrike" dirty="0">
+                  <a:solidFill>
+                    <a:srgbClr val="000000"/>
+                  </a:solidFill>
+                  <a:effectLst/>
+                  <a:latin typeface="Roboto Condensed" pitchFamily="2" charset="0"/>
+                  <a:ea typeface="Roboto Condensed" pitchFamily="2" charset="0"/>
+                </a:rPr>
+                <a:t>CBA 2025 </a:t>
+              </a:r>
+              <a:br>
+                <a:rPr lang="en-CA" sz="1400" b="0" i="0" u="none" strike="noStrike" dirty="0">
+                  <a:solidFill>
+                    <a:srgbClr val="000000"/>
+                  </a:solidFill>
+                  <a:effectLst/>
+                  <a:latin typeface="Roboto Condensed" pitchFamily="2" charset="0"/>
+                  <a:ea typeface="Roboto Condensed" pitchFamily="2" charset="0"/>
+                </a:rPr>
+              </a:br>
+              <a:r>
+                <a:rPr lang="en-CA" sz="1400" b="0" i="0" u="none" strike="noStrike" dirty="0">
+                  <a:solidFill>
+                    <a:srgbClr val="000000"/>
+                  </a:solidFill>
+                  <a:effectLst/>
+                  <a:latin typeface="Roboto Condensed" pitchFamily="2" charset="0"/>
+                  <a:ea typeface="Roboto Condensed" pitchFamily="2" charset="0"/>
+                </a:rPr>
+                <a:t>Bioblitz</a:t>
+              </a:r>
+              <a:endParaRPr lang="en-CA" sz="1400" dirty="0">
+                <a:latin typeface="Roboto Condensed" pitchFamily="2" charset="0"/>
+                <a:ea typeface="Roboto Condensed" pitchFamily="2" charset="0"/>
+              </a:endParaRPr>
+            </a:p>
+          </p:txBody>
+        </p:sp>
+        <p:cxnSp>
+          <p:nvCxnSpPr>
+            <p:cNvPr id="27" name="Straight Arrow Connector 26">
+              <a:extLst>
+                <a:ext uri="{FF2B5EF4-FFF2-40B4-BE49-F238E27FC236}">
+                  <a16:creationId xmlns:a16="http://schemas.microsoft.com/office/drawing/2014/main" id="{A460BCCC-0CBD-1992-1F88-26FDB5FD4C11}"/>
+                </a:ext>
+              </a:extLst>
+            </p:cNvPr>
+            <p:cNvCxnSpPr>
+              <a:cxnSpLocks/>
+            </p:cNvCxnSpPr>
+            <p:nvPr/>
+          </p:nvCxnSpPr>
+          <p:spPr>
+            <a:xfrm flipH="1">
+              <a:off x="9430782" y="3701563"/>
+              <a:ext cx="62986" cy="263298"/>
+            </a:xfrm>
+            <a:prstGeom prst="straightConnector1">
+              <a:avLst/>
+            </a:prstGeom>
+            <a:ln>
+              <a:tailEnd type="triangle"/>
+            </a:ln>
+          </p:spPr>
+          <p:style>
+            <a:lnRef idx="2">
+              <a:schemeClr val="dk1"/>
+            </a:lnRef>
+            <a:fillRef idx="0">
+              <a:schemeClr val="dk1"/>
+            </a:fillRef>
+            <a:effectRef idx="1">
+              <a:schemeClr val="dk1"/>
+            </a:effectRef>
+            <a:fontRef idx="minor">
+              <a:schemeClr val="tx1"/>
+            </a:fontRef>
+          </p:style>
+        </p:cxnSp>
+        <p:sp>
+          <p:nvSpPr>
+            <p:cNvPr id="2" name="TextBox 1">
+              <a:extLst>
+                <a:ext uri="{FF2B5EF4-FFF2-40B4-BE49-F238E27FC236}">
+                  <a16:creationId xmlns:a16="http://schemas.microsoft.com/office/drawing/2014/main" id="{920F3EC9-25ED-ED5D-045E-7FFAC21E65FD}"/>
+                </a:ext>
+              </a:extLst>
+            </p:cNvPr>
+            <p:cNvSpPr txBox="1"/>
+            <p:nvPr/>
+          </p:nvSpPr>
+          <p:spPr>
+            <a:xfrm>
+              <a:off x="8148377" y="2478763"/>
+              <a:ext cx="1351571" cy="523220"/>
+            </a:xfrm>
+            <a:prstGeom prst="rect">
+              <a:avLst/>
+            </a:prstGeom>
+            <a:noFill/>
+          </p:spPr>
+          <p:txBody>
+            <a:bodyPr wrap="square" rtlCol="0">
+              <a:spAutoFit/>
+            </a:bodyPr>
+            <a:lstStyle/>
+            <a:p>
+              <a:pPr algn="r"/>
+              <a:r>
+                <a:rPr lang="en-CA" sz="1400" b="0" i="0" u="none" strike="noStrike" dirty="0">
+                  <a:solidFill>
+                    <a:srgbClr val="000000"/>
+                  </a:solidFill>
+                  <a:effectLst/>
+                  <a:latin typeface="Roboto Condensed" pitchFamily="2" charset="0"/>
+                  <a:ea typeface="Roboto Condensed" pitchFamily="2" charset="0"/>
+                </a:rPr>
+                <a:t>Limestone Barrens Bioblitz</a:t>
+              </a:r>
+              <a:endParaRPr lang="en-CA" sz="1400" dirty="0">
+                <a:latin typeface="Roboto Condensed" pitchFamily="2" charset="0"/>
+                <a:ea typeface="Roboto Condensed" pitchFamily="2" charset="0"/>
+              </a:endParaRPr>
+            </a:p>
+          </p:txBody>
+        </p:sp>
+        <p:cxnSp>
+          <p:nvCxnSpPr>
+            <p:cNvPr id="4" name="Straight Arrow Connector 3">
+              <a:extLst>
+                <a:ext uri="{FF2B5EF4-FFF2-40B4-BE49-F238E27FC236}">
+                  <a16:creationId xmlns:a16="http://schemas.microsoft.com/office/drawing/2014/main" id="{EB74D187-9E36-6517-AB4C-A6D177BDD741}"/>
+                </a:ext>
+              </a:extLst>
+            </p:cNvPr>
+            <p:cNvCxnSpPr>
+              <a:cxnSpLocks/>
+            </p:cNvCxnSpPr>
+            <p:nvPr/>
+          </p:nvCxnSpPr>
+          <p:spPr>
+            <a:xfrm flipH="1">
+              <a:off x="8893869" y="2985918"/>
+              <a:ext cx="173268" cy="651352"/>
+            </a:xfrm>
+            <a:prstGeom prst="straightConnector1">
+              <a:avLst/>
+            </a:prstGeom>
+            <a:ln>
+              <a:tailEnd type="triangle"/>
+            </a:ln>
+          </p:spPr>
+          <p:style>
+            <a:lnRef idx="2">
+              <a:schemeClr val="dk1"/>
+            </a:lnRef>
+            <a:fillRef idx="0">
+              <a:schemeClr val="dk1"/>
+            </a:fillRef>
+            <a:effectRef idx="1">
+              <a:schemeClr val="dk1"/>
+            </a:effectRef>
+            <a:fontRef idx="minor">
+              <a:schemeClr val="tx1"/>
+            </a:fontRef>
+          </p:style>
+        </p:cxnSp>
+        <p:sp>
+          <p:nvSpPr>
+            <p:cNvPr id="46" name="TextBox 45">
+              <a:extLst>
+                <a:ext uri="{FF2B5EF4-FFF2-40B4-BE49-F238E27FC236}">
+                  <a16:creationId xmlns:a16="http://schemas.microsoft.com/office/drawing/2014/main" id="{D2051621-1C77-3F04-5AFF-D806A4CAD325}"/>
+                </a:ext>
+              </a:extLst>
+            </p:cNvPr>
+            <p:cNvSpPr txBox="1"/>
+            <p:nvPr/>
+          </p:nvSpPr>
+          <p:spPr>
+            <a:xfrm>
+              <a:off x="7279331" y="-480101"/>
+              <a:ext cx="1731701" cy="307777"/>
+            </a:xfrm>
+            <a:prstGeom prst="rect">
+              <a:avLst/>
+            </a:prstGeom>
+            <a:noFill/>
+          </p:spPr>
+          <p:txBody>
+            <a:bodyPr wrap="square" rtlCol="0">
+              <a:spAutoFit/>
+            </a:bodyPr>
+            <a:lstStyle/>
+            <a:p>
+              <a:pPr algn="r"/>
+              <a:r>
+                <a:rPr lang="en-CA" sz="1400" b="0" i="0" u="none" strike="noStrike" dirty="0">
+                  <a:solidFill>
+                    <a:srgbClr val="000000"/>
+                  </a:solidFill>
+                  <a:effectLst/>
+                  <a:latin typeface="Roboto Condensed" pitchFamily="2" charset="0"/>
+                  <a:ea typeface="Roboto Condensed" pitchFamily="2" charset="0"/>
+                </a:rPr>
+                <a:t>853</a:t>
+              </a:r>
+              <a:endParaRPr lang="en-CA" sz="1400" dirty="0">
+                <a:latin typeface="Roboto Condensed" pitchFamily="2" charset="0"/>
+                <a:ea typeface="Roboto Condensed" pitchFamily="2" charset="0"/>
+              </a:endParaRPr>
+            </a:p>
+          </p:txBody>
+        </p:sp>
+        <p:grpSp>
+          <p:nvGrpSpPr>
+            <p:cNvPr id="36" name="Group 35">
+              <a:extLst>
+                <a:ext uri="{FF2B5EF4-FFF2-40B4-BE49-F238E27FC236}">
+                  <a16:creationId xmlns:a16="http://schemas.microsoft.com/office/drawing/2014/main" id="{7E0C1D21-97DF-03DF-D9A5-03232345B3BF}"/>
+                </a:ext>
+              </a:extLst>
+            </p:cNvPr>
+            <p:cNvGrpSpPr/>
+            <p:nvPr/>
+          </p:nvGrpSpPr>
+          <p:grpSpPr>
+            <a:xfrm>
+              <a:off x="1680202" y="-1235851"/>
+              <a:ext cx="8446969" cy="10246900"/>
+              <a:chOff x="1680202" y="-1246736"/>
+              <a:chExt cx="8446969" cy="10246900"/>
+            </a:xfrm>
+          </p:grpSpPr>
+          <p:sp>
+            <p:nvSpPr>
+              <p:cNvPr id="12" name="TextBox 11">
+                <a:extLst>
+                  <a:ext uri="{FF2B5EF4-FFF2-40B4-BE49-F238E27FC236}">
+                    <a16:creationId xmlns:a16="http://schemas.microsoft.com/office/drawing/2014/main" id="{D3B9C5C2-3D8E-68C8-C46F-D3021589466F}"/>
+                  </a:ext>
+                </a:extLst>
+              </p:cNvPr>
+              <p:cNvSpPr txBox="1"/>
+              <p:nvPr/>
+            </p:nvSpPr>
+            <p:spPr>
+              <a:xfrm>
+                <a:off x="1922105" y="-1246736"/>
+                <a:ext cx="8078819" cy="369332"/>
+              </a:xfrm>
+              <a:prstGeom prst="rect">
+                <a:avLst/>
+              </a:prstGeom>
+              <a:noFill/>
+            </p:spPr>
+            <p:txBody>
+              <a:bodyPr wrap="square" rtlCol="0">
+                <a:spAutoFit/>
+              </a:bodyPr>
+              <a:lstStyle/>
+              <a:p>
+                <a:pPr algn="ctr"/>
+                <a:r>
+                  <a:rPr lang="en-CA" b="1" dirty="0">
+                    <a:latin typeface="Roboto Condensed" pitchFamily="2" charset="0"/>
+                    <a:ea typeface="Roboto Condensed" pitchFamily="2" charset="0"/>
+                  </a:rPr>
+                  <a:t>New species observed per site</a:t>
+                </a:r>
+              </a:p>
+            </p:txBody>
+          </p:sp>
+          <p:sp>
+            <p:nvSpPr>
+              <p:cNvPr id="15" name="TextBox 14">
+                <a:extLst>
+                  <a:ext uri="{FF2B5EF4-FFF2-40B4-BE49-F238E27FC236}">
+                    <a16:creationId xmlns:a16="http://schemas.microsoft.com/office/drawing/2014/main" id="{5645FEF0-58BC-7956-D5AE-6F51E3FCCBE1}"/>
+                  </a:ext>
+                </a:extLst>
+              </p:cNvPr>
+              <p:cNvSpPr txBox="1"/>
+              <p:nvPr/>
+            </p:nvSpPr>
+            <p:spPr>
+              <a:xfrm>
+                <a:off x="8235589" y="6995868"/>
+                <a:ext cx="1653150" cy="523220"/>
+              </a:xfrm>
+              <a:prstGeom prst="rect">
+                <a:avLst/>
+              </a:prstGeom>
+              <a:noFill/>
+            </p:spPr>
+            <p:txBody>
+              <a:bodyPr wrap="square" rtlCol="0">
+                <a:spAutoFit/>
+              </a:bodyPr>
+              <a:lstStyle/>
+              <a:p>
+                <a:pPr algn="ctr"/>
+                <a:r>
+                  <a:rPr lang="en-CA" sz="1400" b="0" i="0" dirty="0">
+                    <a:effectLst/>
+                    <a:latin typeface="Roboto Condensed" pitchFamily="2" charset="0"/>
+                    <a:ea typeface="Roboto Condensed" pitchFamily="2" charset="0"/>
+                  </a:rPr>
+                  <a:t>Fetid Marigold </a:t>
+                </a:r>
+                <a:br>
+                  <a:rPr lang="en-CA" sz="1400" b="0" i="0" dirty="0">
+                    <a:effectLst/>
+                    <a:latin typeface="Roboto Condensed" pitchFamily="2" charset="0"/>
+                    <a:ea typeface="Roboto Condensed" pitchFamily="2" charset="0"/>
+                  </a:rPr>
+                </a:br>
+                <a:r>
+                  <a:rPr lang="en-CA" sz="1400" b="0" i="1" dirty="0" err="1">
+                    <a:effectLst/>
+                    <a:latin typeface="Roboto Condensed" pitchFamily="2" charset="0"/>
+                    <a:ea typeface="Roboto Condensed" pitchFamily="2" charset="0"/>
+                  </a:rPr>
+                  <a:t>Dyssodia</a:t>
+                </a:r>
+                <a:r>
+                  <a:rPr lang="en-CA" sz="1400" b="0" i="1" dirty="0">
+                    <a:effectLst/>
+                    <a:latin typeface="Roboto Condensed" pitchFamily="2" charset="0"/>
+                    <a:ea typeface="Roboto Condensed" pitchFamily="2" charset="0"/>
+                  </a:rPr>
+                  <a:t> </a:t>
+                </a:r>
+                <a:r>
+                  <a:rPr lang="en-CA" sz="1400" b="0" i="1" dirty="0" err="1">
+                    <a:effectLst/>
+                    <a:latin typeface="Roboto Condensed" pitchFamily="2" charset="0"/>
+                    <a:ea typeface="Roboto Condensed" pitchFamily="2" charset="0"/>
+                  </a:rPr>
+                  <a:t>papposa</a:t>
+                </a:r>
+                <a:endParaRPr lang="en-CA" sz="1400" b="0" i="0" dirty="0">
+                  <a:effectLst/>
+                  <a:latin typeface="Roboto Condensed" pitchFamily="2" charset="0"/>
+                  <a:ea typeface="Roboto Condensed" pitchFamily="2" charset="0"/>
+                </a:endParaRPr>
+              </a:p>
+            </p:txBody>
+          </p:sp>
+          <p:sp>
+            <p:nvSpPr>
+              <p:cNvPr id="16" name="TextBox 15">
+                <a:extLst>
+                  <a:ext uri="{FF2B5EF4-FFF2-40B4-BE49-F238E27FC236}">
+                    <a16:creationId xmlns:a16="http://schemas.microsoft.com/office/drawing/2014/main" id="{8F19428F-14DB-75A3-DDCB-F3D28DF44AF4}"/>
+                  </a:ext>
+                </a:extLst>
+              </p:cNvPr>
+              <p:cNvSpPr txBox="1"/>
+              <p:nvPr/>
+            </p:nvSpPr>
+            <p:spPr>
+              <a:xfrm>
+                <a:off x="5521934" y="6177455"/>
+                <a:ext cx="1718277" cy="523220"/>
+              </a:xfrm>
+              <a:prstGeom prst="rect">
+                <a:avLst/>
+              </a:prstGeom>
+              <a:noFill/>
+            </p:spPr>
+            <p:txBody>
+              <a:bodyPr wrap="square" rtlCol="0">
+                <a:spAutoFit/>
+              </a:bodyPr>
+              <a:lstStyle>
+                <a:defPPr>
+                  <a:defRPr lang="en-US"/>
+                </a:defPPr>
+                <a:lvl1pPr>
+                  <a:defRPr sz="1600" b="0" i="0">
+                    <a:effectLst/>
+                    <a:latin typeface="Roboto Condensed" pitchFamily="2" charset="0"/>
+                    <a:ea typeface="Roboto Condensed" pitchFamily="2" charset="0"/>
+                  </a:defRPr>
+                </a:lvl1pPr>
+              </a:lstStyle>
+              <a:p>
+                <a:r>
+                  <a:rPr lang="en-CA" sz="1400" dirty="0"/>
+                  <a:t>Common </a:t>
+                </a:r>
+                <a:r>
+                  <a:rPr lang="en-CA" sz="1400" dirty="0" err="1"/>
+                  <a:t>Watersnake</a:t>
+                </a:r>
+                <a:endParaRPr lang="en-CA" sz="1400" dirty="0"/>
+              </a:p>
+              <a:p>
+                <a:r>
+                  <a:rPr lang="en-CA" sz="1400" i="1" dirty="0" err="1"/>
+                  <a:t>Nerodia</a:t>
+                </a:r>
+                <a:r>
+                  <a:rPr lang="en-CA" sz="1400" i="1" dirty="0"/>
+                  <a:t> </a:t>
+                </a:r>
+                <a:r>
+                  <a:rPr lang="en-CA" sz="1400" i="1" dirty="0" err="1"/>
+                  <a:t>sipedon</a:t>
+                </a:r>
+                <a:endParaRPr lang="en-CA" sz="1400" i="1" dirty="0"/>
+              </a:p>
+            </p:txBody>
+          </p:sp>
+          <p:sp>
+            <p:nvSpPr>
+              <p:cNvPr id="17" name="TextBox 16">
+                <a:extLst>
+                  <a:ext uri="{FF2B5EF4-FFF2-40B4-BE49-F238E27FC236}">
+                    <a16:creationId xmlns:a16="http://schemas.microsoft.com/office/drawing/2014/main" id="{76044C40-7B02-21AC-1117-5479212BACD8}"/>
+                  </a:ext>
+                </a:extLst>
+              </p:cNvPr>
+              <p:cNvSpPr txBox="1"/>
+              <p:nvPr/>
+            </p:nvSpPr>
+            <p:spPr>
+              <a:xfrm>
+                <a:off x="7580212" y="7851052"/>
+                <a:ext cx="2546959" cy="523220"/>
+              </a:xfrm>
+              <a:prstGeom prst="rect">
+                <a:avLst/>
+              </a:prstGeom>
+              <a:noFill/>
+            </p:spPr>
+            <p:txBody>
+              <a:bodyPr wrap="square" rtlCol="0">
+                <a:spAutoFit/>
+              </a:bodyPr>
+              <a:lstStyle/>
+              <a:p>
+                <a:r>
+                  <a:rPr lang="en-CA" sz="1400" b="0" i="0" dirty="0">
+                    <a:effectLst/>
+                    <a:latin typeface="Roboto Condensed" pitchFamily="2" charset="0"/>
+                    <a:ea typeface="Roboto Condensed" pitchFamily="2" charset="0"/>
+                  </a:rPr>
+                  <a:t>Vancouver Island Marmot</a:t>
+                </a:r>
+              </a:p>
+              <a:p>
+                <a:r>
+                  <a:rPr lang="en-CA" sz="1400" b="0" i="1" dirty="0">
+                    <a:effectLst/>
+                    <a:latin typeface="Roboto Condensed" pitchFamily="2" charset="0"/>
+                    <a:ea typeface="Roboto Condensed" pitchFamily="2" charset="0"/>
+                  </a:rPr>
+                  <a:t>Marmota </a:t>
+                </a:r>
+                <a:r>
+                  <a:rPr lang="en-CA" sz="1400" b="0" i="1" dirty="0" err="1">
+                    <a:effectLst/>
+                    <a:latin typeface="Roboto Condensed" pitchFamily="2" charset="0"/>
+                    <a:ea typeface="Roboto Condensed" pitchFamily="2" charset="0"/>
+                  </a:rPr>
+                  <a:t>vancouverensis</a:t>
+                </a:r>
+                <a:endParaRPr lang="en-CA" sz="1400" b="0" i="1" dirty="0">
+                  <a:effectLst/>
+                  <a:latin typeface="Roboto Condensed" pitchFamily="2" charset="0"/>
+                  <a:ea typeface="Roboto Condensed" pitchFamily="2" charset="0"/>
+                </a:endParaRPr>
+              </a:p>
+            </p:txBody>
+          </p:sp>
+          <p:sp>
+            <p:nvSpPr>
+              <p:cNvPr id="19" name="TextBox 18">
+                <a:extLst>
+                  <a:ext uri="{FF2B5EF4-FFF2-40B4-BE49-F238E27FC236}">
+                    <a16:creationId xmlns:a16="http://schemas.microsoft.com/office/drawing/2014/main" id="{23ED1302-0B2F-4818-776E-62E1A06ACBD8}"/>
+                  </a:ext>
+                </a:extLst>
+              </p:cNvPr>
+              <p:cNvSpPr txBox="1"/>
+              <p:nvPr/>
+            </p:nvSpPr>
+            <p:spPr>
+              <a:xfrm>
+                <a:off x="5613693" y="8415389"/>
+                <a:ext cx="4375748" cy="584775"/>
+              </a:xfrm>
+              <a:prstGeom prst="rect">
+                <a:avLst/>
+              </a:prstGeom>
+              <a:noFill/>
+            </p:spPr>
+            <p:txBody>
+              <a:bodyPr wrap="square" rtlCol="0">
+                <a:spAutoFit/>
+              </a:bodyPr>
+              <a:lstStyle>
+                <a:defPPr>
+                  <a:defRPr lang="en-US"/>
+                </a:defPPr>
+                <a:lvl1pPr>
+                  <a:defRPr sz="1400" b="0" i="0">
+                    <a:effectLst/>
+                    <a:latin typeface="Roboto Condensed" pitchFamily="2" charset="0"/>
+                    <a:ea typeface="Roboto Condensed" pitchFamily="2" charset="0"/>
+                  </a:defRPr>
+                </a:lvl1pPr>
+              </a:lstStyle>
+              <a:p>
+                <a:r>
+                  <a:rPr lang="en-CA" dirty="0"/>
+                  <a:t>Clouded Sulphur</a:t>
+                </a:r>
+              </a:p>
+              <a:p>
+                <a:r>
+                  <a:rPr lang="en-CA" i="1" dirty="0"/>
+                  <a:t>Colias </a:t>
+                </a:r>
+                <a:r>
+                  <a:rPr lang="en-CA" i="1" dirty="0" err="1"/>
+                  <a:t>philodice</a:t>
+                </a:r>
+                <a:r>
+                  <a:rPr lang="en-CA" i="1" dirty="0"/>
+                  <a:t> </a:t>
+                </a:r>
+              </a:p>
+            </p:txBody>
+          </p:sp>
+          <p:sp>
+            <p:nvSpPr>
+              <p:cNvPr id="21" name="TextBox 20">
+                <a:extLst>
+                  <a:ext uri="{FF2B5EF4-FFF2-40B4-BE49-F238E27FC236}">
+                    <a16:creationId xmlns:a16="http://schemas.microsoft.com/office/drawing/2014/main" id="{BE4FFADB-F74E-116D-F1D5-ECD38F2363CC}"/>
+                  </a:ext>
+                </a:extLst>
+              </p:cNvPr>
+              <p:cNvSpPr txBox="1"/>
+              <p:nvPr/>
+            </p:nvSpPr>
+            <p:spPr>
+              <a:xfrm>
+                <a:off x="5521934" y="6798154"/>
+                <a:ext cx="2047644" cy="523220"/>
+              </a:xfrm>
+              <a:prstGeom prst="rect">
+                <a:avLst/>
+              </a:prstGeom>
+              <a:noFill/>
+            </p:spPr>
+            <p:txBody>
+              <a:bodyPr wrap="square" rtlCol="0">
+                <a:spAutoFit/>
+              </a:bodyPr>
+              <a:lstStyle>
+                <a:defPPr>
+                  <a:defRPr lang="en-US"/>
+                </a:defPPr>
+                <a:lvl1pPr>
+                  <a:defRPr sz="1600" b="0" i="0">
+                    <a:effectLst/>
+                    <a:latin typeface="Roboto Condensed" pitchFamily="2" charset="0"/>
+                    <a:ea typeface="Roboto Condensed" pitchFamily="2" charset="0"/>
+                  </a:defRPr>
+                </a:lvl1pPr>
+              </a:lstStyle>
+              <a:p>
+                <a:r>
+                  <a:rPr lang="en-CA" sz="1400" dirty="0"/>
+                  <a:t>Red-legged frog </a:t>
+                </a:r>
+                <a:br>
+                  <a:rPr lang="en-CA" sz="1400" dirty="0"/>
+                </a:br>
+                <a:r>
+                  <a:rPr lang="en-CA" sz="1400" i="1" dirty="0"/>
+                  <a:t>Rana aurora</a:t>
+                </a:r>
+              </a:p>
+            </p:txBody>
+          </p:sp>
+          <p:cxnSp>
+            <p:nvCxnSpPr>
+              <p:cNvPr id="23" name="Straight Arrow Connector 22">
+                <a:extLst>
+                  <a:ext uri="{FF2B5EF4-FFF2-40B4-BE49-F238E27FC236}">
+                    <a16:creationId xmlns:a16="http://schemas.microsoft.com/office/drawing/2014/main" id="{E4FF210C-154D-E9A2-FC57-6007519871CA}"/>
+                  </a:ext>
+                </a:extLst>
+              </p:cNvPr>
+              <p:cNvCxnSpPr>
+                <a:cxnSpLocks/>
+              </p:cNvCxnSpPr>
+              <p:nvPr/>
+            </p:nvCxnSpPr>
+            <p:spPr>
+              <a:xfrm flipH="1">
+                <a:off x="4890920" y="6422410"/>
+                <a:ext cx="631014" cy="0"/>
+              </a:xfrm>
+              <a:prstGeom prst="straightConnector1">
+                <a:avLst/>
+              </a:prstGeom>
+              <a:ln>
+                <a:tailEnd type="triangle"/>
+              </a:ln>
+            </p:spPr>
+            <p:style>
+              <a:lnRef idx="2">
+                <a:schemeClr val="dk1"/>
+              </a:lnRef>
+              <a:fillRef idx="0">
+                <a:schemeClr val="dk1"/>
+              </a:fillRef>
+              <a:effectRef idx="1">
+                <a:schemeClr val="dk1"/>
+              </a:effectRef>
+              <a:fontRef idx="minor">
+                <a:schemeClr val="tx1"/>
+              </a:fontRef>
+            </p:style>
+          </p:cxnSp>
+          <p:cxnSp>
+            <p:nvCxnSpPr>
+              <p:cNvPr id="29" name="Straight Arrow Connector 28">
+                <a:extLst>
+                  <a:ext uri="{FF2B5EF4-FFF2-40B4-BE49-F238E27FC236}">
+                    <a16:creationId xmlns:a16="http://schemas.microsoft.com/office/drawing/2014/main" id="{0EE586B1-48E5-C86C-4A01-4327F88F63AA}"/>
+                  </a:ext>
+                </a:extLst>
+              </p:cNvPr>
+              <p:cNvCxnSpPr>
+                <a:cxnSpLocks/>
+              </p:cNvCxnSpPr>
+              <p:nvPr/>
+            </p:nvCxnSpPr>
+            <p:spPr>
+              <a:xfrm flipH="1">
+                <a:off x="7129670" y="8114129"/>
+                <a:ext cx="450542" cy="0"/>
+              </a:xfrm>
+              <a:prstGeom prst="straightConnector1">
+                <a:avLst/>
+              </a:prstGeom>
+              <a:ln>
+                <a:tailEnd type="triangle"/>
+              </a:ln>
+            </p:spPr>
+            <p:style>
+              <a:lnRef idx="2">
+                <a:schemeClr val="dk1"/>
+              </a:lnRef>
+              <a:fillRef idx="0">
+                <a:schemeClr val="dk1"/>
+              </a:fillRef>
+              <a:effectRef idx="1">
+                <a:schemeClr val="dk1"/>
+              </a:effectRef>
+              <a:fontRef idx="minor">
+                <a:schemeClr val="tx1"/>
+              </a:fontRef>
+            </p:style>
+          </p:cxnSp>
+          <p:cxnSp>
+            <p:nvCxnSpPr>
+              <p:cNvPr id="31" name="Straight Arrow Connector 30">
+                <a:extLst>
+                  <a:ext uri="{FF2B5EF4-FFF2-40B4-BE49-F238E27FC236}">
+                    <a16:creationId xmlns:a16="http://schemas.microsoft.com/office/drawing/2014/main" id="{C7482208-ED7E-5EB5-4500-17EBFE548E13}"/>
+                  </a:ext>
+                </a:extLst>
+              </p:cNvPr>
+              <p:cNvCxnSpPr>
+                <a:cxnSpLocks/>
+              </p:cNvCxnSpPr>
+              <p:nvPr/>
+            </p:nvCxnSpPr>
+            <p:spPr>
+              <a:xfrm flipH="1">
+                <a:off x="5192049" y="8654650"/>
+                <a:ext cx="454696" cy="0"/>
+              </a:xfrm>
+              <a:prstGeom prst="straightConnector1">
+                <a:avLst/>
+              </a:prstGeom>
+              <a:ln>
+                <a:tailEnd type="triangle"/>
+              </a:ln>
+            </p:spPr>
+            <p:style>
+              <a:lnRef idx="2">
+                <a:schemeClr val="dk1"/>
+              </a:lnRef>
+              <a:fillRef idx="0">
+                <a:schemeClr val="dk1"/>
+              </a:fillRef>
+              <a:effectRef idx="1">
+                <a:schemeClr val="dk1"/>
+              </a:effectRef>
+              <a:fontRef idx="minor">
+                <a:schemeClr val="tx1"/>
+              </a:fontRef>
+            </p:style>
+          </p:cxnSp>
+          <p:cxnSp>
+            <p:nvCxnSpPr>
+              <p:cNvPr id="32" name="Straight Arrow Connector 31">
+                <a:extLst>
+                  <a:ext uri="{FF2B5EF4-FFF2-40B4-BE49-F238E27FC236}">
+                    <a16:creationId xmlns:a16="http://schemas.microsoft.com/office/drawing/2014/main" id="{1255D950-3ADE-A056-0FA8-6F4D27396872}"/>
+                  </a:ext>
+                </a:extLst>
+              </p:cNvPr>
+              <p:cNvCxnSpPr>
+                <a:cxnSpLocks/>
+              </p:cNvCxnSpPr>
+              <p:nvPr/>
+            </p:nvCxnSpPr>
+            <p:spPr>
+              <a:xfrm flipH="1">
+                <a:off x="4912544" y="7021664"/>
+                <a:ext cx="609390" cy="0"/>
+              </a:xfrm>
+              <a:prstGeom prst="straightConnector1">
+                <a:avLst/>
+              </a:prstGeom>
+              <a:ln>
+                <a:tailEnd type="triangle"/>
+              </a:ln>
+            </p:spPr>
+            <p:style>
+              <a:lnRef idx="2">
+                <a:schemeClr val="dk1"/>
+              </a:lnRef>
+              <a:fillRef idx="0">
+                <a:schemeClr val="dk1"/>
+              </a:fillRef>
+              <a:effectRef idx="1">
+                <a:schemeClr val="dk1"/>
+              </a:effectRef>
+              <a:fontRef idx="minor">
+                <a:schemeClr val="tx1"/>
+              </a:fontRef>
+            </p:style>
+          </p:cxnSp>
+          <p:sp>
+            <p:nvSpPr>
+              <p:cNvPr id="26" name="TextBox 25">
+                <a:extLst>
+                  <a:ext uri="{FF2B5EF4-FFF2-40B4-BE49-F238E27FC236}">
+                    <a16:creationId xmlns:a16="http://schemas.microsoft.com/office/drawing/2014/main" id="{EF499BE8-A295-ED21-1D39-03D2EFE155F2}"/>
+                  </a:ext>
+                </a:extLst>
+              </p:cNvPr>
+              <p:cNvSpPr txBox="1"/>
+              <p:nvPr/>
+            </p:nvSpPr>
+            <p:spPr>
+              <a:xfrm>
+                <a:off x="1690822" y="6265654"/>
+                <a:ext cx="1718277" cy="369332"/>
+              </a:xfrm>
+              <a:prstGeom prst="rect">
+                <a:avLst/>
+              </a:prstGeom>
+              <a:noFill/>
+            </p:spPr>
+            <p:txBody>
+              <a:bodyPr wrap="square" rtlCol="0">
+                <a:spAutoFit/>
+              </a:bodyPr>
+              <a:lstStyle>
+                <a:defPPr>
+                  <a:defRPr lang="en-US"/>
+                </a:defPPr>
+                <a:lvl1pPr>
+                  <a:defRPr sz="1600" b="0" i="0">
+                    <a:effectLst/>
+                    <a:latin typeface="Roboto Condensed" pitchFamily="2" charset="0"/>
+                    <a:ea typeface="Roboto Condensed" pitchFamily="2" charset="0"/>
+                  </a:defRPr>
+                </a:lvl1pPr>
+              </a:lstStyle>
+              <a:p>
+                <a:pPr algn="r"/>
+                <a:r>
+                  <a:rPr lang="en-CA" sz="1800" b="1" dirty="0"/>
+                  <a:t>Reptiles</a:t>
+                </a:r>
+                <a:endParaRPr lang="en-CA" sz="1800" b="1" i="1" dirty="0"/>
+              </a:p>
+            </p:txBody>
+          </p:sp>
+          <p:sp>
+            <p:nvSpPr>
+              <p:cNvPr id="28" name="TextBox 27">
+                <a:extLst>
+                  <a:ext uri="{FF2B5EF4-FFF2-40B4-BE49-F238E27FC236}">
+                    <a16:creationId xmlns:a16="http://schemas.microsoft.com/office/drawing/2014/main" id="{5BE77108-DF25-7F5B-4397-18D3E8ABD51B}"/>
+                  </a:ext>
+                </a:extLst>
+              </p:cNvPr>
+              <p:cNvSpPr txBox="1"/>
+              <p:nvPr/>
+            </p:nvSpPr>
+            <p:spPr>
+              <a:xfrm>
+                <a:off x="1690822" y="6857368"/>
+                <a:ext cx="1718277" cy="369332"/>
+              </a:xfrm>
+              <a:prstGeom prst="rect">
+                <a:avLst/>
+              </a:prstGeom>
+              <a:noFill/>
+            </p:spPr>
+            <p:txBody>
+              <a:bodyPr wrap="square" rtlCol="0">
+                <a:spAutoFit/>
+              </a:bodyPr>
+              <a:lstStyle>
+                <a:defPPr>
+                  <a:defRPr lang="en-US"/>
+                </a:defPPr>
+                <a:lvl1pPr>
+                  <a:defRPr sz="1600" b="0" i="0">
+                    <a:effectLst/>
+                    <a:latin typeface="Roboto Condensed" pitchFamily="2" charset="0"/>
+                    <a:ea typeface="Roboto Condensed" pitchFamily="2" charset="0"/>
+                  </a:defRPr>
+                </a:lvl1pPr>
+              </a:lstStyle>
+              <a:p>
+                <a:pPr algn="r"/>
+                <a:r>
+                  <a:rPr lang="en-CA" sz="1800" b="1" dirty="0"/>
+                  <a:t>Amphibians</a:t>
+                </a:r>
+                <a:endParaRPr lang="en-CA" sz="1800" b="1" i="1" dirty="0"/>
+              </a:p>
+            </p:txBody>
+          </p:sp>
+          <p:sp>
+            <p:nvSpPr>
+              <p:cNvPr id="30" name="TextBox 29">
+                <a:extLst>
+                  <a:ext uri="{FF2B5EF4-FFF2-40B4-BE49-F238E27FC236}">
+                    <a16:creationId xmlns:a16="http://schemas.microsoft.com/office/drawing/2014/main" id="{ABF0D8A7-A78D-58EA-9E4A-0878661666F1}"/>
+                  </a:ext>
+                </a:extLst>
+              </p:cNvPr>
+              <p:cNvSpPr txBox="1"/>
+              <p:nvPr/>
+            </p:nvSpPr>
+            <p:spPr>
+              <a:xfrm>
+                <a:off x="1690822" y="7398239"/>
+                <a:ext cx="1718277" cy="369332"/>
+              </a:xfrm>
+              <a:prstGeom prst="rect">
+                <a:avLst/>
+              </a:prstGeom>
+              <a:noFill/>
+            </p:spPr>
+            <p:txBody>
+              <a:bodyPr wrap="square" rtlCol="0">
+                <a:spAutoFit/>
+              </a:bodyPr>
+              <a:lstStyle>
+                <a:defPPr>
+                  <a:defRPr lang="en-US"/>
+                </a:defPPr>
+                <a:lvl1pPr>
+                  <a:defRPr sz="1600" b="0" i="0">
+                    <a:effectLst/>
+                    <a:latin typeface="Roboto Condensed" pitchFamily="2" charset="0"/>
+                    <a:ea typeface="Roboto Condensed" pitchFamily="2" charset="0"/>
+                  </a:defRPr>
+                </a:lvl1pPr>
+              </a:lstStyle>
+              <a:p>
+                <a:pPr algn="r"/>
+                <a:r>
+                  <a:rPr lang="en-CA" sz="1800" b="1" dirty="0"/>
+                  <a:t>Plants</a:t>
+                </a:r>
+                <a:endParaRPr lang="en-CA" sz="1800" b="1" i="1" dirty="0"/>
+              </a:p>
+            </p:txBody>
+          </p:sp>
+          <p:sp>
+            <p:nvSpPr>
+              <p:cNvPr id="33" name="TextBox 32">
+                <a:extLst>
+                  <a:ext uri="{FF2B5EF4-FFF2-40B4-BE49-F238E27FC236}">
+                    <a16:creationId xmlns:a16="http://schemas.microsoft.com/office/drawing/2014/main" id="{B201A54C-FDCC-FEF1-D6F6-E87B522B5FFA}"/>
+                  </a:ext>
+                </a:extLst>
+              </p:cNvPr>
+              <p:cNvSpPr txBox="1"/>
+              <p:nvPr/>
+            </p:nvSpPr>
+            <p:spPr>
+              <a:xfrm>
+                <a:off x="1690822" y="7939111"/>
+                <a:ext cx="1718277" cy="369332"/>
+              </a:xfrm>
+              <a:prstGeom prst="rect">
+                <a:avLst/>
+              </a:prstGeom>
+              <a:noFill/>
+            </p:spPr>
+            <p:txBody>
+              <a:bodyPr wrap="square" rtlCol="0">
+                <a:spAutoFit/>
+              </a:bodyPr>
+              <a:lstStyle>
+                <a:defPPr>
+                  <a:defRPr lang="en-US"/>
+                </a:defPPr>
+                <a:lvl1pPr>
+                  <a:defRPr sz="1600" b="0" i="0">
+                    <a:effectLst/>
+                    <a:latin typeface="Roboto Condensed" pitchFamily="2" charset="0"/>
+                    <a:ea typeface="Roboto Condensed" pitchFamily="2" charset="0"/>
+                  </a:defRPr>
+                </a:lvl1pPr>
+              </a:lstStyle>
+              <a:p>
+                <a:pPr algn="r"/>
+                <a:r>
+                  <a:rPr lang="en-CA" sz="1800" b="1" dirty="0"/>
+                  <a:t>Mammals</a:t>
+                </a:r>
+                <a:endParaRPr lang="en-CA" sz="1800" b="1" i="1" dirty="0"/>
+              </a:p>
+            </p:txBody>
+          </p:sp>
+          <p:sp>
+            <p:nvSpPr>
+              <p:cNvPr id="34" name="TextBox 33">
+                <a:extLst>
+                  <a:ext uri="{FF2B5EF4-FFF2-40B4-BE49-F238E27FC236}">
+                    <a16:creationId xmlns:a16="http://schemas.microsoft.com/office/drawing/2014/main" id="{046A768F-EE41-90F4-CD8C-6EEA657AB45A}"/>
+                  </a:ext>
+                </a:extLst>
+              </p:cNvPr>
+              <p:cNvSpPr txBox="1"/>
+              <p:nvPr/>
+            </p:nvSpPr>
+            <p:spPr>
+              <a:xfrm>
+                <a:off x="1680202" y="8479983"/>
+                <a:ext cx="1718277" cy="369332"/>
+              </a:xfrm>
+              <a:prstGeom prst="rect">
+                <a:avLst/>
+              </a:prstGeom>
+              <a:noFill/>
+            </p:spPr>
+            <p:txBody>
+              <a:bodyPr wrap="square" rtlCol="0">
+                <a:spAutoFit/>
+              </a:bodyPr>
+              <a:lstStyle>
+                <a:defPPr>
+                  <a:defRPr lang="en-US"/>
+                </a:defPPr>
+                <a:lvl1pPr>
+                  <a:defRPr sz="1600" b="0" i="0">
+                    <a:effectLst/>
+                    <a:latin typeface="Roboto Condensed" pitchFamily="2" charset="0"/>
+                    <a:ea typeface="Roboto Condensed" pitchFamily="2" charset="0"/>
+                  </a:defRPr>
+                </a:lvl1pPr>
+              </a:lstStyle>
+              <a:p>
+                <a:pPr algn="r"/>
+                <a:r>
+                  <a:rPr lang="en-CA" sz="1800" b="1" dirty="0"/>
+                  <a:t>Butterflies</a:t>
+                </a:r>
+                <a:endParaRPr lang="en-CA" sz="1800" b="1" i="1" dirty="0"/>
+              </a:p>
+            </p:txBody>
+          </p:sp>
+        </p:grpSp>
+      </p:grpSp>
+    </p:spTree>
+    <p:extLst>
+      <p:ext uri="{BB962C8B-B14F-4D97-AF65-F5344CB8AC3E}">
+        <p14:creationId xmlns:p14="http://schemas.microsoft.com/office/powerpoint/2010/main" val="158162484"/>
       </p:ext>
     </p:extLst>
   </p:cSld>
@@ -4896,4 +6734,319 @@
     </a:ext>
   </a:extLst>
 </a:theme>
+</file>
+
+<file path=ppt/theme/theme2.xml><?xml version="1.0" encoding="utf-8"?>
+<a:theme xmlns:a="http://schemas.openxmlformats.org/drawingml/2006/main" name="Office Theme">
+  <a:themeElements>
+    <a:clrScheme name="Office">
+      <a:dk1>
+        <a:sysClr val="windowText" lastClr="000000"/>
+      </a:dk1>
+      <a:lt1>
+        <a:sysClr val="window" lastClr="FFFFFF"/>
+      </a:lt1>
+      <a:dk2>
+        <a:srgbClr val="0E2841"/>
+      </a:dk2>
+      <a:lt2>
+        <a:srgbClr val="E8E8E8"/>
+      </a:lt2>
+      <a:accent1>
+        <a:srgbClr val="156082"/>
+      </a:accent1>
+      <a:accent2>
+        <a:srgbClr val="E97132"/>
+      </a:accent2>
+      <a:accent3>
+        <a:srgbClr val="196B24"/>
+      </a:accent3>
+      <a:accent4>
+        <a:srgbClr val="0F9ED5"/>
+      </a:accent4>
+      <a:accent5>
+        <a:srgbClr val="A02B93"/>
+      </a:accent5>
+      <a:accent6>
+        <a:srgbClr val="4EA72E"/>
+      </a:accent6>
+      <a:hlink>
+        <a:srgbClr val="467886"/>
+      </a:hlink>
+      <a:folHlink>
+        <a:srgbClr val="96607D"/>
+      </a:folHlink>
+    </a:clrScheme>
+    <a:fontScheme name="Office">
+      <a:majorFont>
+        <a:latin typeface="Aptos Display" panose="02110004020202020204"/>
+        <a:ea typeface=""/>
+        <a:cs typeface=""/>
+        <a:font script="Jpan" typeface="游ゴシック Light"/>
+        <a:font script="Hang" typeface="맑은 고딕"/>
+        <a:font script="Hans" typeface="等线 Light"/>
+        <a:font script="Hant" typeface="新細明體"/>
+        <a:font script="Arab" typeface="Times New Roman"/>
+        <a:font script="Hebr" typeface="Times New Roman"/>
+        <a:font script="Thai" typeface="Angsana New"/>
+        <a:font script="Ethi" typeface="Nyala"/>
+        <a:font script="Beng" typeface="Vrinda"/>
+        <a:font script="Gujr" typeface="Shruti"/>
+        <a:font script="Khmr" typeface="MoolBoran"/>
+        <a:font script="Knda" typeface="Tunga"/>
+        <a:font script="Guru" typeface="Raavi"/>
+        <a:font script="Cans" typeface="Euphemia"/>
+        <a:font script="Cher" typeface="Plantagenet Cherokee"/>
+        <a:font script="Yiii" typeface="Microsoft Yi Baiti"/>
+        <a:font script="Tibt" typeface="Microsoft Himalaya"/>
+        <a:font script="Thaa" typeface="MV Boli"/>
+        <a:font script="Deva" typeface="Mangal"/>
+        <a:font script="Telu" typeface="Gautami"/>
+        <a:font script="Taml" typeface="Latha"/>
+        <a:font script="Syrc" typeface="Estrangelo Edessa"/>
+        <a:font script="Orya" typeface="Kalinga"/>
+        <a:font script="Mlym" typeface="Kartika"/>
+        <a:font script="Laoo" typeface="DokChampa"/>
+        <a:font script="Sinh" typeface="Iskoola Pota"/>
+        <a:font script="Mong" typeface="Mongolian Baiti"/>
+        <a:font script="Viet" typeface="Times New Roman"/>
+        <a:font script="Uigh" typeface="Microsoft Uighur"/>
+        <a:font script="Geor" typeface="Sylfaen"/>
+        <a:font script="Armn" typeface="Arial"/>
+        <a:font script="Bugi" typeface="Leelawadee UI"/>
+        <a:font script="Bopo" typeface="Microsoft JhengHei"/>
+        <a:font script="Java" typeface="Javanese Text"/>
+        <a:font script="Lisu" typeface="Segoe UI"/>
+        <a:font script="Mymr" typeface="Myanmar Text"/>
+        <a:font script="Nkoo" typeface="Ebrima"/>
+        <a:font script="Olck" typeface="Nirmala UI"/>
+        <a:font script="Osma" typeface="Ebrima"/>
+        <a:font script="Phag" typeface="Phagspa"/>
+        <a:font script="Syrn" typeface="Estrangelo Edessa"/>
+        <a:font script="Syrj" typeface="Estrangelo Edessa"/>
+        <a:font script="Syre" typeface="Estrangelo Edessa"/>
+        <a:font script="Sora" typeface="Nirmala UI"/>
+        <a:font script="Tale" typeface="Microsoft Tai Le"/>
+        <a:font script="Talu" typeface="Microsoft New Tai Lue"/>
+        <a:font script="Tfng" typeface="Ebrima"/>
+      </a:majorFont>
+      <a:minorFont>
+        <a:latin typeface="Aptos" panose="02110004020202020204"/>
+        <a:ea typeface=""/>
+        <a:cs typeface=""/>
+        <a:font script="Jpan" typeface="游ゴシック"/>
+        <a:font script="Hang" typeface="맑은 고딕"/>
+        <a:font script="Hans" typeface="等线"/>
+        <a:font script="Hant" typeface="新細明體"/>
+        <a:font script="Arab" typeface="Arial"/>
+        <a:font script="Hebr" typeface="Arial"/>
+        <a:font script="Thai" typeface="Cordia New"/>
+        <a:font script="Ethi" typeface="Nyala"/>
+        <a:font script="Beng" typeface="Vrinda"/>
+        <a:font script="Gujr" typeface="Shruti"/>
+        <a:font script="Khmr" typeface="DaunPenh"/>
+        <a:font script="Knda" typeface="Tunga"/>
+        <a:font script="Guru" typeface="Raavi"/>
+        <a:font script="Cans" typeface="Euphemia"/>
+        <a:font script="Cher" typeface="Plantagenet Cherokee"/>
+        <a:font script="Yiii" typeface="Microsoft Yi Baiti"/>
+        <a:font script="Tibt" typeface="Microsoft Himalaya"/>
+        <a:font script="Thaa" typeface="MV Boli"/>
+        <a:font script="Deva" typeface="Mangal"/>
+        <a:font script="Telu" typeface="Gautami"/>
+        <a:font script="Taml" typeface="Latha"/>
+        <a:font script="Syrc" typeface="Estrangelo Edessa"/>
+        <a:font script="Orya" typeface="Kalinga"/>
+        <a:font script="Mlym" typeface="Kartika"/>
+        <a:font script="Laoo" typeface="DokChampa"/>
+        <a:font script="Sinh" typeface="Iskoola Pota"/>
+        <a:font script="Mong" typeface="Mongolian Baiti"/>
+        <a:font script="Viet" typeface="Arial"/>
+        <a:font script="Uigh" typeface="Microsoft Uighur"/>
+        <a:font script="Geor" typeface="Sylfaen"/>
+        <a:font script="Armn" typeface="Arial"/>
+        <a:font script="Bugi" typeface="Leelawadee UI"/>
+        <a:font script="Bopo" typeface="Microsoft JhengHei"/>
+        <a:font script="Java" typeface="Javanese Text"/>
+        <a:font script="Lisu" typeface="Segoe UI"/>
+        <a:font script="Mymr" typeface="Myanmar Text"/>
+        <a:font script="Nkoo" typeface="Ebrima"/>
+        <a:font script="Olck" typeface="Nirmala UI"/>
+        <a:font script="Osma" typeface="Ebrima"/>
+        <a:font script="Phag" typeface="Phagspa"/>
+        <a:font script="Syrn" typeface="Estrangelo Edessa"/>
+        <a:font script="Syrj" typeface="Estrangelo Edessa"/>
+        <a:font script="Syre" typeface="Estrangelo Edessa"/>
+        <a:font script="Sora" typeface="Nirmala UI"/>
+        <a:font script="Tale" typeface="Microsoft Tai Le"/>
+        <a:font script="Talu" typeface="Microsoft New Tai Lue"/>
+        <a:font script="Tfng" typeface="Ebrima"/>
+      </a:minorFont>
+    </a:fontScheme>
+    <a:fmtScheme name="Office">
+      <a:fillStyleLst>
+        <a:solidFill>
+          <a:schemeClr val="phClr"/>
+        </a:solidFill>
+        <a:gradFill rotWithShape="1">
+          <a:gsLst>
+            <a:gs pos="0">
+              <a:schemeClr val="phClr">
+                <a:lumMod val="110000"/>
+                <a:satMod val="105000"/>
+                <a:tint val="67000"/>
+              </a:schemeClr>
+            </a:gs>
+            <a:gs pos="50000">
+              <a:schemeClr val="phClr">
+                <a:lumMod val="105000"/>
+                <a:satMod val="103000"/>
+                <a:tint val="73000"/>
+              </a:schemeClr>
+            </a:gs>
+            <a:gs pos="100000">
+              <a:schemeClr val="phClr">
+                <a:lumMod val="105000"/>
+                <a:satMod val="109000"/>
+                <a:tint val="81000"/>
+              </a:schemeClr>
+            </a:gs>
+          </a:gsLst>
+          <a:lin ang="5400000" scaled="0"/>
+        </a:gradFill>
+        <a:gradFill rotWithShape="1">
+          <a:gsLst>
+            <a:gs pos="0">
+              <a:schemeClr val="phClr">
+                <a:satMod val="103000"/>
+                <a:lumMod val="102000"/>
+                <a:tint val="94000"/>
+              </a:schemeClr>
+            </a:gs>
+            <a:gs pos="50000">
+              <a:schemeClr val="phClr">
+                <a:satMod val="110000"/>
+                <a:lumMod val="100000"/>
+                <a:shade val="100000"/>
+              </a:schemeClr>
+            </a:gs>
+            <a:gs pos="100000">
+              <a:schemeClr val="phClr">
+                <a:lumMod val="99000"/>
+                <a:satMod val="120000"/>
+                <a:shade val="78000"/>
+              </a:schemeClr>
+            </a:gs>
+          </a:gsLst>
+          <a:lin ang="5400000" scaled="0"/>
+        </a:gradFill>
+      </a:fillStyleLst>
+      <a:lnStyleLst>
+        <a:ln w="12700" cap="flat" cmpd="sng" algn="ctr">
+          <a:solidFill>
+            <a:schemeClr val="phClr"/>
+          </a:solidFill>
+          <a:prstDash val="solid"/>
+          <a:miter lim="800000"/>
+        </a:ln>
+        <a:ln w="19050" cap="flat" cmpd="sng" algn="ctr">
+          <a:solidFill>
+            <a:schemeClr val="phClr"/>
+          </a:solidFill>
+          <a:prstDash val="solid"/>
+          <a:miter lim="800000"/>
+        </a:ln>
+        <a:ln w="25400" cap="flat" cmpd="sng" algn="ctr">
+          <a:solidFill>
+            <a:schemeClr val="phClr"/>
+          </a:solidFill>
+          <a:prstDash val="solid"/>
+          <a:miter lim="800000"/>
+        </a:ln>
+      </a:lnStyleLst>
+      <a:effectStyleLst>
+        <a:effectStyle>
+          <a:effectLst/>
+        </a:effectStyle>
+        <a:effectStyle>
+          <a:effectLst/>
+        </a:effectStyle>
+        <a:effectStyle>
+          <a:effectLst>
+            <a:outerShdw blurRad="57150" dist="19050" dir="5400000" algn="ctr" rotWithShape="0">
+              <a:srgbClr val="000000">
+                <a:alpha val="63000"/>
+              </a:srgbClr>
+            </a:outerShdw>
+          </a:effectLst>
+        </a:effectStyle>
+      </a:effectStyleLst>
+      <a:bgFillStyleLst>
+        <a:solidFill>
+          <a:schemeClr val="phClr"/>
+        </a:solidFill>
+        <a:solidFill>
+          <a:schemeClr val="phClr">
+            <a:tint val="95000"/>
+            <a:satMod val="170000"/>
+          </a:schemeClr>
+        </a:solidFill>
+        <a:gradFill rotWithShape="1">
+          <a:gsLst>
+            <a:gs pos="0">
+              <a:schemeClr val="phClr">
+                <a:tint val="93000"/>
+                <a:satMod val="150000"/>
+                <a:shade val="98000"/>
+                <a:lumMod val="102000"/>
+              </a:schemeClr>
+            </a:gs>
+            <a:gs pos="50000">
+              <a:schemeClr val="phClr">
+                <a:tint val="98000"/>
+                <a:satMod val="130000"/>
+                <a:shade val="90000"/>
+                <a:lumMod val="103000"/>
+              </a:schemeClr>
+            </a:gs>
+            <a:gs pos="100000">
+              <a:schemeClr val="phClr">
+                <a:shade val="63000"/>
+                <a:satMod val="120000"/>
+              </a:schemeClr>
+            </a:gs>
+          </a:gsLst>
+          <a:lin ang="5400000" scaled="0"/>
+        </a:gradFill>
+      </a:bgFillStyleLst>
+    </a:fmtScheme>
+  </a:themeElements>
+  <a:objectDefaults>
+    <a:lnDef>
+      <a:spPr/>
+      <a:bodyPr/>
+      <a:lstStyle/>
+      <a:style>
+        <a:lnRef idx="2">
+          <a:schemeClr val="accent1"/>
+        </a:lnRef>
+        <a:fillRef idx="0">
+          <a:schemeClr val="accent1"/>
+        </a:fillRef>
+        <a:effectRef idx="1">
+          <a:schemeClr val="accent1"/>
+        </a:effectRef>
+        <a:fontRef idx="minor">
+          <a:schemeClr val="tx1"/>
+        </a:fontRef>
+      </a:style>
+    </a:lnDef>
+  </a:objectDefaults>
+  <a:extraClrSchemeLst/>
+  <a:extLst>
+    <a:ext uri="{05A4C25C-085E-4340-85A3-A5531E510DB2}">
+      <thm15:themeFamily xmlns:thm15="http://schemas.microsoft.com/office/thememl/2012/main" name="Office Theme" id="{2E142A2C-CD16-42D6-873A-C26D2A0506FA}" vid="{1BDDFF52-6CD6-40A5-AB3C-68EB2F1E4D0A}"/>
+    </a:ext>
+  </a:extLst>
+</a:theme>
 </file>
</xml_diff>